<commit_message>
feat: enhance pitch deck with high-contrast dark NPCI logo and impactful slide layouts
</commit_message>
<xml_diff>
--- a/CitiFlow_Escrow_Pitch_Deck.pptx
+++ b/CitiFlow_Escrow_Pitch_Deck.pptx
@@ -3181,9 +3181,54 @@
           </a:p>
         </p:txBody>
       </p:sp>
+      <p:sp>
+        <p:nvSpPr>
+          <p:cNvPr id="4" name="Rounded Rectangle 3"/>
+          <p:cNvSpPr/>
+          <p:nvPr/>
+        </p:nvSpPr>
+        <p:spPr>
+          <a:xfrm>
+            <a:off x="777240" y="777240"/>
+            <a:ext cx="3931920" cy="1051560"/>
+          </a:xfrm>
+          <a:prstGeom prst="roundRect">
+            <a:avLst/>
+          </a:prstGeom>
+          <a:solidFill>
+            <a:srgbClr val="FFFFFF"/>
+          </a:solidFill>
+          <a:ln w="19050">
+            <a:solidFill>
+              <a:srgbClr val="C8DCF5"/>
+            </a:solidFill>
+          </a:ln>
+        </p:spPr>
+        <p:style>
+          <a:lnRef idx="1">
+            <a:schemeClr val="accent1"/>
+          </a:lnRef>
+          <a:fillRef idx="3">
+            <a:schemeClr val="accent1"/>
+          </a:fillRef>
+          <a:effectRef idx="2">
+            <a:schemeClr val="accent1"/>
+          </a:effectRef>
+          <a:fontRef idx="minor">
+            <a:schemeClr val="lt1"/>
+          </a:fontRef>
+        </p:style>
+        <p:txBody>
+          <a:bodyPr rtlCol="0" anchor="ctr"/>
+          <a:lstStyle/>
+          <a:p>
+            <a:pPr algn="ctr"/>
+          </a:p>
+        </p:txBody>
+      </p:sp>
       <p:pic>
         <p:nvPicPr>
-          <p:cNvPr id="4" name="Picture 3" descr="citi_logo.png"/>
+          <p:cNvPr id="5" name="Picture 4" descr="citi_logo.png"/>
           <p:cNvPicPr>
             <a:picLocks noChangeAspect="1"/>
           </p:cNvPicPr>
@@ -3197,17 +3242,60 @@
         </p:blipFill>
         <p:spPr>
           <a:xfrm>
-            <a:off x="822960" y="914400"/>
-            <a:ext cx="1645920" cy="1645920"/>
+            <a:off x="1005840" y="1024128"/>
+            <a:ext cx="1280160" cy="1280160"/>
           </a:xfrm>
           <a:prstGeom prst="rect">
             <a:avLst/>
           </a:prstGeom>
         </p:spPr>
       </p:pic>
+      <p:sp>
+        <p:nvSpPr>
+          <p:cNvPr id="6" name="Rectangle 5"/>
+          <p:cNvSpPr/>
+          <p:nvPr/>
+        </p:nvSpPr>
+        <p:spPr>
+          <a:xfrm>
+            <a:off x="2514600" y="960120"/>
+            <a:ext cx="18288" cy="685800"/>
+          </a:xfrm>
+          <a:prstGeom prst="rect">
+            <a:avLst/>
+          </a:prstGeom>
+          <a:solidFill>
+            <a:srgbClr val="CBD5E1"/>
+          </a:solidFill>
+          <a:ln>
+            <a:noFill/>
+          </a:ln>
+        </p:spPr>
+        <p:style>
+          <a:lnRef idx="1">
+            <a:schemeClr val="accent1"/>
+          </a:lnRef>
+          <a:fillRef idx="3">
+            <a:schemeClr val="accent1"/>
+          </a:fillRef>
+          <a:effectRef idx="2">
+            <a:schemeClr val="accent1"/>
+          </a:effectRef>
+          <a:fontRef idx="minor">
+            <a:schemeClr val="lt1"/>
+          </a:fontRef>
+        </p:style>
+        <p:txBody>
+          <a:bodyPr rtlCol="0" anchor="ctr"/>
+          <a:lstStyle/>
+          <a:p>
+            <a:pPr algn="ctr"/>
+          </a:p>
+        </p:txBody>
+      </p:sp>
       <p:pic>
         <p:nvPicPr>
-          <p:cNvPr id="5" name="Picture 4" descr="npci_logo.png"/>
+          <p:cNvPr id="7" name="Picture 6" descr="npci_logo.png"/>
           <p:cNvPicPr>
             <a:picLocks noChangeAspect="1"/>
           </p:cNvPicPr>
@@ -3221,24 +3309,48 @@
         </p:blipFill>
         <p:spPr>
           <a:xfrm>
-            <a:off x="2926080" y="960120"/>
-            <a:ext cx="1737360" cy="539467"/>
+            <a:off x="2697480" y="1051560"/>
+            <a:ext cx="1783080" cy="553663"/>
           </a:xfrm>
           <a:prstGeom prst="rect">
             <a:avLst/>
           </a:prstGeom>
         </p:spPr>
       </p:pic>
-      <p:sp>
-        <p:nvSpPr>
-          <p:cNvPr id="6" name="TextBox 5"/>
+      <p:pic>
+        <p:nvPicPr>
+          <p:cNvPr id="8" name="Picture 7" descr="npci_logo_dark.png"/>
+          <p:cNvPicPr>
+            <a:picLocks noChangeAspect="1"/>
+          </p:cNvPicPr>
+          <p:nvPr/>
+        </p:nvPicPr>
+        <p:blipFill>
+          <a:blip r:embed="rId4"/>
+          <a:stretch>
+            <a:fillRect/>
+          </a:stretch>
+        </p:blipFill>
+        <p:spPr>
+          <a:xfrm>
+            <a:off x="9326880" y="822960"/>
+            <a:ext cx="2103120" cy="653039"/>
+          </a:xfrm>
+          <a:prstGeom prst="rect">
+            <a:avLst/>
+          </a:prstGeom>
+        </p:spPr>
+      </p:pic>
+      <p:sp>
+        <p:nvSpPr>
+          <p:cNvPr id="9" name="TextBox 8"/>
           <p:cNvSpPr txBox="1"/>
           <p:nvPr/>
         </p:nvSpPr>
         <p:spPr>
           <a:xfrm>
-            <a:off x="822960" y="2011680"/>
-            <a:ext cx="10515600" cy="2926080"/>
+            <a:off x="777240" y="2103120"/>
+            <a:ext cx="10607040" cy="2926080"/>
           </a:xfrm>
           <a:prstGeom prst="rect">
             <a:avLst/>
@@ -3252,7 +3364,7 @@
           <a:lstStyle/>
           <a:p>
             <a:pPr>
-              <a:defRPr sz="4400" b="1">
+              <a:defRPr sz="4600" b="1">
                 <a:solidFill>
                   <a:srgbClr val="FFFFFF"/>
                 </a:solidFill>
@@ -3265,11 +3377,11 @@
           <a:p>
             <a:pPr>
               <a:spcBef>
-                <a:spcPts val="1400"/>
+                <a:spcPts val="1200"/>
               </a:spcBef>
-              <a:defRPr sz="2000">
-                <a:solidFill>
-                  <a:srgbClr val="A0CDF0"/>
+              <a:defRPr sz="2100" b="1">
+                <a:solidFill>
+                  <a:srgbClr val="93C5FD"/>
                 </a:solidFill>
               </a:defRPr>
             </a:pPr>
@@ -3282,28 +3394,28 @@
               <a:spcBef>
                 <a:spcPts val="1000"/>
               </a:spcBef>
-              <a:defRPr sz="1400">
-                <a:solidFill>
-                  <a:srgbClr val="D2E1F0"/>
-                </a:solidFill>
-              </a:defRPr>
-            </a:pPr>
-            <a:r>
-              <a:t>Bridging Citibank Global Treasury &amp; FX Rails with NPCI Sovereign Rails on Drunix L1 Blockchain</a:t>
-            </a:r>
-          </a:p>
-        </p:txBody>
-      </p:sp>
-      <p:sp>
-        <p:nvSpPr>
-          <p:cNvPr id="7" name="Rounded Rectangle 6"/>
+              <a:defRPr sz="1450">
+                <a:solidFill>
+                  <a:srgbClr val="E2E8F0"/>
+                </a:solidFill>
+              </a:defRPr>
+            </a:pPr>
+            <a:r>
+              <a:t>Bridging Citibank Global Treasury Infrastructure &amp; Live FX with NPCI Sovereign Real-Time Rails on Drunix L1 Blockchain</a:t>
+            </a:r>
+          </a:p>
+        </p:txBody>
+      </p:sp>
+      <p:sp>
+        <p:nvSpPr>
+          <p:cNvPr id="10" name="Rounded Rectangle 9"/>
           <p:cNvSpPr/>
           <p:nvPr/>
         </p:nvSpPr>
         <p:spPr>
           <a:xfrm>
-            <a:off x="822960" y="5394960"/>
-            <a:ext cx="1920240" cy="411480"/>
+            <a:off x="777240" y="5440680"/>
+            <a:ext cx="1993392" cy="438912"/>
           </a:xfrm>
           <a:prstGeom prst="roundRect">
             <a:avLst/>
@@ -3311,9 +3423,9 @@
           <a:solidFill>
             <a:srgbClr val="FFFFFF"/>
           </a:solidFill>
-          <a:ln>
+          <a:ln w="15240">
             <a:solidFill>
-              <a:srgbClr val="C8DCF5"/>
+              <a:srgbClr val="CBD5E1"/>
             </a:solidFill>
           </a:ln>
         </p:spPr>
@@ -3336,7 +3448,7 @@
           <a:lstStyle/>
           <a:p>
             <a:pPr algn="ctr">
-              <a:defRPr sz="1000" b="1">
+              <a:defRPr sz="1050" b="1">
                 <a:solidFill>
                   <a:srgbClr val="002D72"/>
                 </a:solidFill>
@@ -3350,14 +3462,14 @@
       </p:sp>
       <p:sp>
         <p:nvSpPr>
-          <p:cNvPr id="8" name="Rounded Rectangle 7"/>
+          <p:cNvPr id="11" name="Rounded Rectangle 10"/>
           <p:cNvSpPr/>
           <p:nvPr/>
         </p:nvSpPr>
         <p:spPr>
           <a:xfrm>
-            <a:off x="2926079" y="5394960"/>
-            <a:ext cx="1920240" cy="411480"/>
+            <a:off x="2953512" y="5440680"/>
+            <a:ext cx="1993392" cy="438912"/>
           </a:xfrm>
           <a:prstGeom prst="roundRect">
             <a:avLst/>
@@ -3365,9 +3477,9 @@
           <a:solidFill>
             <a:srgbClr val="FFFFFF"/>
           </a:solidFill>
-          <a:ln>
+          <a:ln w="15240">
             <a:solidFill>
-              <a:srgbClr val="C8DCF5"/>
+              <a:srgbClr val="CBD5E1"/>
             </a:solidFill>
           </a:ln>
         </p:spPr>
@@ -3390,7 +3502,7 @@
           <a:lstStyle/>
           <a:p>
             <a:pPr algn="ctr">
-              <a:defRPr sz="1000" b="1">
+              <a:defRPr sz="1050" b="1">
                 <a:solidFill>
                   <a:srgbClr val="002D72"/>
                 </a:solidFill>
@@ -3404,14 +3516,14 @@
       </p:sp>
       <p:sp>
         <p:nvSpPr>
-          <p:cNvPr id="9" name="Rounded Rectangle 8"/>
+          <p:cNvPr id="12" name="Rounded Rectangle 11"/>
           <p:cNvSpPr/>
           <p:nvPr/>
         </p:nvSpPr>
         <p:spPr>
           <a:xfrm>
-            <a:off x="5029200" y="5394960"/>
-            <a:ext cx="1920240" cy="411480"/>
+            <a:off x="5129783" y="5440680"/>
+            <a:ext cx="1993392" cy="438912"/>
           </a:xfrm>
           <a:prstGeom prst="roundRect">
             <a:avLst/>
@@ -3419,9 +3531,9 @@
           <a:solidFill>
             <a:srgbClr val="FFFFFF"/>
           </a:solidFill>
-          <a:ln>
+          <a:ln w="15240">
             <a:solidFill>
-              <a:srgbClr val="C8DCF5"/>
+              <a:srgbClr val="CBD5E1"/>
             </a:solidFill>
           </a:ln>
         </p:spPr>
@@ -3444,7 +3556,7 @@
           <a:lstStyle/>
           <a:p>
             <a:pPr algn="ctr">
-              <a:defRPr sz="1000" b="1">
+              <a:defRPr sz="1050" b="1">
                 <a:solidFill>
                   <a:srgbClr val="002D72"/>
                 </a:solidFill>
@@ -3458,14 +3570,14 @@
       </p:sp>
       <p:sp>
         <p:nvSpPr>
-          <p:cNvPr id="10" name="Rounded Rectangle 9"/>
+          <p:cNvPr id="13" name="Rounded Rectangle 12"/>
           <p:cNvSpPr/>
           <p:nvPr/>
         </p:nvSpPr>
         <p:spPr>
           <a:xfrm>
-            <a:off x="7132320" y="5394960"/>
-            <a:ext cx="1920240" cy="411480"/>
+            <a:off x="7306055" y="5440680"/>
+            <a:ext cx="1993392" cy="438912"/>
           </a:xfrm>
           <a:prstGeom prst="roundRect">
             <a:avLst/>
@@ -3473,9 +3585,9 @@
           <a:solidFill>
             <a:srgbClr val="FFFFFF"/>
           </a:solidFill>
-          <a:ln>
+          <a:ln w="15240">
             <a:solidFill>
-              <a:srgbClr val="C8DCF5"/>
+              <a:srgbClr val="CBD5E1"/>
             </a:solidFill>
           </a:ln>
         </p:spPr>
@@ -3498,7 +3610,7 @@
           <a:lstStyle/>
           <a:p>
             <a:pPr algn="ctr">
-              <a:defRPr sz="1000" b="1">
+              <a:defRPr sz="1050" b="1">
                 <a:solidFill>
                   <a:srgbClr val="002D72"/>
                 </a:solidFill>
@@ -3512,14 +3624,14 @@
       </p:sp>
       <p:sp>
         <p:nvSpPr>
-          <p:cNvPr id="11" name="Rounded Rectangle 10"/>
+          <p:cNvPr id="14" name="Rounded Rectangle 13"/>
           <p:cNvSpPr/>
           <p:nvPr/>
         </p:nvSpPr>
         <p:spPr>
           <a:xfrm>
-            <a:off x="9235440" y="5394960"/>
-            <a:ext cx="1920240" cy="411480"/>
+            <a:off x="9482328" y="5440680"/>
+            <a:ext cx="1993392" cy="438912"/>
           </a:xfrm>
           <a:prstGeom prst="roundRect">
             <a:avLst/>
@@ -3527,9 +3639,9 @@
           <a:solidFill>
             <a:srgbClr val="FFFFFF"/>
           </a:solidFill>
-          <a:ln>
+          <a:ln w="15240">
             <a:solidFill>
-              <a:srgbClr val="C8DCF5"/>
+              <a:srgbClr val="CBD5E1"/>
             </a:solidFill>
           </a:ln>
         </p:spPr>
@@ -3552,7 +3664,7 @@
           <a:lstStyle/>
           <a:p>
             <a:pPr algn="ctr">
-              <a:defRPr sz="1000" b="1">
+              <a:defRPr sz="1050" b="1">
                 <a:solidFill>
                   <a:srgbClr val="002D72"/>
                 </a:solidFill>
@@ -3627,14 +3739,59 @@
       </p:sp>
       <p:sp>
         <p:nvSpPr>
-          <p:cNvPr id="3" name="TextBox 2"/>
+          <p:cNvPr id="3" name="Rectangle 2"/>
+          <p:cNvSpPr/>
+          <p:nvPr/>
+        </p:nvSpPr>
+        <p:spPr>
+          <a:xfrm>
+            <a:off x="0" y="73152"/>
+            <a:ext cx="12191695" cy="1051560"/>
+          </a:xfrm>
+          <a:prstGeom prst="rect">
+            <a:avLst/>
+          </a:prstGeom>
+          <a:solidFill>
+            <a:srgbClr val="FFFFFF"/>
+          </a:solidFill>
+          <a:ln w="12700">
+            <a:solidFill>
+              <a:srgbClr val="E2E8F0"/>
+            </a:solidFill>
+          </a:ln>
+        </p:spPr>
+        <p:style>
+          <a:lnRef idx="1">
+            <a:schemeClr val="accent1"/>
+          </a:lnRef>
+          <a:fillRef idx="3">
+            <a:schemeClr val="accent1"/>
+          </a:fillRef>
+          <a:effectRef idx="2">
+            <a:schemeClr val="accent1"/>
+          </a:effectRef>
+          <a:fontRef idx="minor">
+            <a:schemeClr val="lt1"/>
+          </a:fontRef>
+        </p:style>
+        <p:txBody>
+          <a:bodyPr rtlCol="0" anchor="ctr"/>
+          <a:lstStyle/>
+          <a:p>
+            <a:pPr algn="ctr"/>
+          </a:p>
+        </p:txBody>
+      </p:sp>
+      <p:sp>
+        <p:nvSpPr>
+          <p:cNvPr id="4" name="TextBox 3"/>
           <p:cNvSpPr txBox="1"/>
           <p:nvPr/>
         </p:nvSpPr>
         <p:spPr>
           <a:xfrm>
-            <a:off x="731520" y="228600"/>
-            <a:ext cx="7772400" cy="320040"/>
+            <a:off x="731520" y="164592"/>
+            <a:ext cx="7772400" cy="256032"/>
           </a:xfrm>
           <a:prstGeom prst="rect">
             <a:avLst/>
@@ -3655,20 +3812,20 @@
               </a:defRPr>
             </a:pPr>
             <a:r>
-              <a:t>CITIFLOW ESCROW | INSTITUTIONAL TRADE &amp; DVP</a:t>
-            </a:r>
-          </a:p>
-        </p:txBody>
-      </p:sp>
-      <p:sp>
-        <p:nvSpPr>
-          <p:cNvPr id="4" name="TextBox 3"/>
+              <a:t>CITIFLOW ESCROW | INSTITUTIONAL TRADE SETTLEMENT</a:t>
+            </a:r>
+          </a:p>
+        </p:txBody>
+      </p:sp>
+      <p:sp>
+        <p:nvSpPr>
+          <p:cNvPr id="5" name="TextBox 4"/>
           <p:cNvSpPr txBox="1"/>
           <p:nvPr/>
         </p:nvSpPr>
         <p:spPr>
           <a:xfrm>
-            <a:off x="731520" y="502920"/>
+            <a:off x="731520" y="438912"/>
             <a:ext cx="8686800" cy="594360"/>
           </a:xfrm>
           <a:prstGeom prst="rect">
@@ -3683,21 +3840,21 @@
           <a:lstStyle/>
           <a:p>
             <a:pPr>
-              <a:defRPr sz="2200" b="1">
+              <a:defRPr sz="2100" b="1">
                 <a:solidFill>
                   <a:srgbClr val="002D72"/>
                 </a:solidFill>
               </a:defRPr>
             </a:pPr>
             <a:r>
-              <a:t>The Problem: The $2.5 Trillion Global Trade Trust &amp; Liquidity Trap</a:t>
+              <a:t>The Problem: The $2.5 Trillion Global Trade Trust &amp; Working Capital Trap</a:t>
             </a:r>
           </a:p>
         </p:txBody>
       </p:sp>
       <p:pic>
         <p:nvPicPr>
-          <p:cNvPr id="5" name="Picture 4" descr="citi_logo.png"/>
+          <p:cNvPr id="6" name="Picture 5" descr="citi_logo.png"/>
           <p:cNvPicPr>
             <a:picLocks noChangeAspect="1"/>
           </p:cNvPicPr>
@@ -3711,8 +3868,8 @@
         </p:blipFill>
         <p:spPr>
           <a:xfrm>
-            <a:off x="10424160" y="292608"/>
-            <a:ext cx="1051560" cy="1051560"/>
+            <a:off x="10607040" y="292608"/>
+            <a:ext cx="960120" cy="960120"/>
           </a:xfrm>
           <a:prstGeom prst="rect">
             <a:avLst/>
@@ -3721,14 +3878,14 @@
       </p:pic>
       <p:sp>
         <p:nvSpPr>
-          <p:cNvPr id="6" name="Rounded Rectangle 5"/>
+          <p:cNvPr id="7" name="Rounded Rectangle 6"/>
           <p:cNvSpPr/>
           <p:nvPr/>
         </p:nvSpPr>
         <p:spPr>
           <a:xfrm>
-            <a:off x="731520" y="1325880"/>
-            <a:ext cx="5257800" cy="2194560"/>
+            <a:off x="777240" y="1325880"/>
+            <a:ext cx="5257800" cy="2212848"/>
           </a:xfrm>
           <a:prstGeom prst="roundRect">
             <a:avLst/>
@@ -3766,14 +3923,14 @@
       </p:sp>
       <p:sp>
         <p:nvSpPr>
-          <p:cNvPr id="7" name="TextBox 6"/>
+          <p:cNvPr id="8" name="TextBox 7"/>
           <p:cNvSpPr txBox="1"/>
           <p:nvPr/>
         </p:nvSpPr>
         <p:spPr>
           <a:xfrm>
-            <a:off x="960120" y="1508760"/>
-            <a:ext cx="4800600" cy="1828800"/>
+            <a:off x="1005840" y="1490472"/>
+            <a:ext cx="4800600" cy="1874519"/>
           </a:xfrm>
           <a:prstGeom prst="rect">
             <a:avLst/>
@@ -3787,43 +3944,58 @@
           <a:lstStyle/>
           <a:p>
             <a:pPr>
-              <a:defRPr sz="1600" b="1">
+              <a:defRPr sz="1550" b="1">
                 <a:solidFill>
                   <a:srgbClr val="002D72"/>
                 </a:solidFill>
               </a:defRPr>
             </a:pPr>
             <a:r>
-              <a:t>🚨 Counterparty Default Risk</a:t>
+              <a:t>🚨 Counterparty Default &amp; Mistrust</a:t>
             </a:r>
           </a:p>
           <a:p>
             <a:pPr>
               <a:spcBef>
-                <a:spcPts val="800"/>
+                <a:spcPts val="300"/>
               </a:spcBef>
-              <a:defRPr sz="1200">
-                <a:solidFill>
-                  <a:srgbClr val="212529"/>
-                </a:solidFill>
-              </a:defRPr>
-            </a:pPr>
-            <a:r>
-              <a:t>Suppliers fear producing high-value goods without 100% advance; buyers fear paying upfront without verified quality, bills of lading, and customs inspection.</a:t>
-            </a:r>
-          </a:p>
-        </p:txBody>
-      </p:sp>
-      <p:sp>
-        <p:nvSpPr>
-          <p:cNvPr id="8" name="Rounded Rectangle 7"/>
+              <a:defRPr sz="1100" b="1">
+                <a:solidFill>
+                  <a:srgbClr val="EF4444"/>
+                </a:solidFill>
+              </a:defRPr>
+            </a:pPr>
+            <a:r>
+              <a:t>Metric: $2.5 Trillion Unmet SME Trade Demand</a:t>
+            </a:r>
+          </a:p>
+          <a:p>
+            <a:pPr>
+              <a:spcBef>
+                <a:spcPts val="600"/>
+              </a:spcBef>
+              <a:defRPr sz="1100">
+                <a:solidFill>
+                  <a:srgbClr val="1E293B"/>
+                </a:solidFill>
+              </a:defRPr>
+            </a:pPr>
+            <a:r>
+              <a:t>Exporters refuse to begin manufacturing high-value goods without advance payments; importers fear paying upfront without verified quality, bills of lading, and customs inspection.</a:t>
+            </a:r>
+          </a:p>
+        </p:txBody>
+      </p:sp>
+      <p:sp>
+        <p:nvSpPr>
+          <p:cNvPr id="9" name="Rounded Rectangle 8"/>
           <p:cNvSpPr/>
           <p:nvPr/>
         </p:nvSpPr>
         <p:spPr>
           <a:xfrm>
-            <a:off x="6172200" y="1325880"/>
-            <a:ext cx="5257800" cy="2194560"/>
+            <a:off x="6217920" y="1325880"/>
+            <a:ext cx="5257800" cy="2212848"/>
           </a:xfrm>
           <a:prstGeom prst="roundRect">
             <a:avLst/>
@@ -3861,14 +4033,14 @@
       </p:sp>
       <p:sp>
         <p:nvSpPr>
-          <p:cNvPr id="9" name="TextBox 8"/>
+          <p:cNvPr id="10" name="TextBox 9"/>
           <p:cNvSpPr txBox="1"/>
           <p:nvPr/>
         </p:nvSpPr>
         <p:spPr>
           <a:xfrm>
-            <a:off x="6400800" y="1508760"/>
-            <a:ext cx="4800600" cy="1828800"/>
+            <a:off x="6446520" y="1490472"/>
+            <a:ext cx="4800600" cy="1874519"/>
           </a:xfrm>
           <a:prstGeom prst="rect">
             <a:avLst/>
@@ -3882,43 +4054,58 @@
           <a:lstStyle/>
           <a:p>
             <a:pPr>
-              <a:defRPr sz="1600" b="1">
+              <a:defRPr sz="1550" b="1">
                 <a:solidFill>
                   <a:srgbClr val="002D72"/>
                 </a:solidFill>
               </a:defRPr>
             </a:pPr>
             <a:r>
-              <a:t>⏳ Trapped Working Capital (LCs)</a:t>
+              <a:t>⏳ Trapped Liquidity in Legacy LCs</a:t>
             </a:r>
           </a:p>
           <a:p>
             <a:pPr>
               <a:spcBef>
-                <a:spcPts val="800"/>
+                <a:spcPts val="300"/>
               </a:spcBef>
-              <a:defRPr sz="1200">
-                <a:solidFill>
-                  <a:srgbClr val="212529"/>
-                </a:solidFill>
-              </a:defRPr>
-            </a:pPr>
-            <a:r>
-              <a:t>Traditional Letters of Credit take 14 to 28 days to process, incur 2% to 4% in bank intermediation fees, and rely on slow paper-heavy workflows.</a:t>
-            </a:r>
-          </a:p>
-        </p:txBody>
-      </p:sp>
-      <p:sp>
-        <p:nvSpPr>
-          <p:cNvPr id="10" name="Rounded Rectangle 9"/>
+              <a:defRPr sz="1100" b="1">
+                <a:solidFill>
+                  <a:srgbClr val="F59E0B"/>
+                </a:solidFill>
+              </a:defRPr>
+            </a:pPr>
+            <a:r>
+              <a:t>Metric: 14 to 28 Days Processing &amp; 2% - 4% Fees</a:t>
+            </a:r>
+          </a:p>
+          <a:p>
+            <a:pPr>
+              <a:spcBef>
+                <a:spcPts val="600"/>
+              </a:spcBef>
+              <a:defRPr sz="1100">
+                <a:solidFill>
+                  <a:srgbClr val="1E293B"/>
+                </a:solidFill>
+              </a:defRPr>
+            </a:pPr>
+            <a:r>
+              <a:t>Traditional Letters of Credit (LCs) lock up enterprise working capital for weeks, incur heavy bank intermediation fees, and rely on cumbersome manual paper documentation.</a:t>
+            </a:r>
+          </a:p>
+        </p:txBody>
+      </p:sp>
+      <p:sp>
+        <p:nvSpPr>
+          <p:cNvPr id="11" name="Rounded Rectangle 10"/>
           <p:cNvSpPr/>
           <p:nvPr/>
         </p:nvSpPr>
         <p:spPr>
           <a:xfrm>
-            <a:off x="731520" y="3749039"/>
-            <a:ext cx="5257800" cy="2194560"/>
+            <a:off x="777240" y="3749039"/>
+            <a:ext cx="5257800" cy="2212848"/>
           </a:xfrm>
           <a:prstGeom prst="roundRect">
             <a:avLst/>
@@ -3956,14 +4143,14 @@
       </p:sp>
       <p:sp>
         <p:nvSpPr>
-          <p:cNvPr id="11" name="TextBox 10"/>
+          <p:cNvPr id="12" name="TextBox 11"/>
           <p:cNvSpPr txBox="1"/>
           <p:nvPr/>
         </p:nvSpPr>
         <p:spPr>
           <a:xfrm>
-            <a:off x="960120" y="3931920"/>
-            <a:ext cx="4800600" cy="1828800"/>
+            <a:off x="1005840" y="3913631"/>
+            <a:ext cx="4800600" cy="1874519"/>
           </a:xfrm>
           <a:prstGeom prst="rect">
             <a:avLst/>
@@ -3977,43 +4164,58 @@
           <a:lstStyle/>
           <a:p>
             <a:pPr>
-              <a:defRPr sz="1600" b="1">
+              <a:defRPr sz="1550" b="1">
                 <a:solidFill>
                   <a:srgbClr val="002D72"/>
                 </a:solidFill>
               </a:defRPr>
             </a:pPr>
             <a:r>
-              <a:t>🔗 Siloed Banking &amp; Telemetry</a:t>
+              <a:t>🔗 Siloed Payment &amp; Logistics Telemetry</a:t>
             </a:r>
           </a:p>
           <a:p>
             <a:pPr>
               <a:spcBef>
-                <a:spcPts val="800"/>
+                <a:spcPts val="300"/>
               </a:spcBef>
-              <a:defRPr sz="1200">
-                <a:solidFill>
-                  <a:srgbClr val="212529"/>
-                </a:solidFill>
-              </a:defRPr>
-            </a:pPr>
-            <a:r>
-              <a:t>Domestic real-time payment rails (UPI) and global SWIFT corridors do not natively connect to supply chain events (ICEGATE, vessel AIS, IoT sensors).</a:t>
-            </a:r>
-          </a:p>
-        </p:txBody>
-      </p:sp>
-      <p:sp>
-        <p:nvSpPr>
-          <p:cNvPr id="12" name="Rounded Rectangle 11"/>
+              <a:defRPr sz="1100" b="1">
+                <a:solidFill>
+                  <a:srgbClr val="3B82F6"/>
+                </a:solidFill>
+              </a:defRPr>
+            </a:pPr>
+            <a:r>
+              <a:t>Metric: Zero Real-Time Cross-Rail Connectivity</a:t>
+            </a:r>
+          </a:p>
+          <a:p>
+            <a:pPr>
+              <a:spcBef>
+                <a:spcPts val="600"/>
+              </a:spcBef>
+              <a:defRPr sz="1100">
+                <a:solidFill>
+                  <a:srgbClr val="1E293B"/>
+                </a:solidFill>
+              </a:defRPr>
+            </a:pPr>
+            <a:r>
+              <a:t>Domestic real-time payment rails (UPI) and global SWIFT corridors do not natively connect to supply chain events (ICEGATE Customs, shipping container AIS, IoT temperature sensors).</a:t>
+            </a:r>
+          </a:p>
+        </p:txBody>
+      </p:sp>
+      <p:sp>
+        <p:nvSpPr>
+          <p:cNvPr id="13" name="Rounded Rectangle 12"/>
           <p:cNvSpPr/>
           <p:nvPr/>
         </p:nvSpPr>
         <p:spPr>
           <a:xfrm>
-            <a:off x="6172200" y="3749039"/>
-            <a:ext cx="5257800" cy="2194560"/>
+            <a:off x="6217920" y="3749039"/>
+            <a:ext cx="5257800" cy="2212848"/>
           </a:xfrm>
           <a:prstGeom prst="roundRect">
             <a:avLst/>
@@ -4051,14 +4253,14 @@
       </p:sp>
       <p:sp>
         <p:nvSpPr>
-          <p:cNvPr id="13" name="TextBox 12"/>
+          <p:cNvPr id="14" name="TextBox 13"/>
           <p:cNvSpPr txBox="1"/>
           <p:nvPr/>
         </p:nvSpPr>
         <p:spPr>
           <a:xfrm>
-            <a:off x="6400800" y="3931920"/>
-            <a:ext cx="4800600" cy="1828800"/>
+            <a:off x="6446520" y="3913631"/>
+            <a:ext cx="4800600" cy="1874519"/>
           </a:xfrm>
           <a:prstGeom prst="rect">
             <a:avLst/>
@@ -4072,29 +4274,44 @@
           <a:lstStyle/>
           <a:p>
             <a:pPr>
-              <a:defRPr sz="1600" b="1">
+              <a:defRPr sz="1550" b="1">
                 <a:solidFill>
                   <a:srgbClr val="002D72"/>
                 </a:solidFill>
               </a:defRPr>
             </a:pPr>
             <a:r>
-              <a:t>📄 Zero Delivery vs. Payment (DvP)</a:t>
+              <a:t>📄 Absence of Delivery vs. Payment (DvP)</a:t>
             </a:r>
           </a:p>
           <a:p>
             <a:pPr>
               <a:spcBef>
-                <a:spcPts val="800"/>
+                <a:spcPts val="300"/>
               </a:spcBef>
-              <a:defRPr sz="1200">
-                <a:solidFill>
-                  <a:srgbClr val="212529"/>
-                </a:solidFill>
-              </a:defRPr>
-            </a:pPr>
-            <a:r>
-              <a:t>Cargo ownership title (Bill of Lading) is physically couriered separately from payments, creating reconciliation latency, duplicate financing, and fraud.</a:t>
+              <a:defRPr sz="1100" b="1">
+                <a:solidFill>
+                  <a:srgbClr val="8B5CF6"/>
+                </a:solidFill>
+              </a:defRPr>
+            </a:pPr>
+            <a:r>
+              <a:t>Metric: Physical Paper Courier &amp; Duplicate Financing</a:t>
+            </a:r>
+          </a:p>
+          <a:p>
+            <a:pPr>
+              <a:spcBef>
+                <a:spcPts val="600"/>
+              </a:spcBef>
+              <a:defRPr sz="1100">
+                <a:solidFill>
+                  <a:srgbClr val="1E293B"/>
+                </a:solidFill>
+              </a:defRPr>
+            </a:pPr>
+            <a:r>
+              <a:t>Cargo ownership titles (Bills of Lading) are physically couriered separately from payments, creating reconciliation delays, duplicate invoice financing, and title fraud.</a:t>
             </a:r>
           </a:p>
         </p:txBody>
@@ -4162,14 +4379,59 @@
       </p:sp>
       <p:sp>
         <p:nvSpPr>
-          <p:cNvPr id="3" name="TextBox 2"/>
+          <p:cNvPr id="3" name="Rectangle 2"/>
+          <p:cNvSpPr/>
+          <p:nvPr/>
+        </p:nvSpPr>
+        <p:spPr>
+          <a:xfrm>
+            <a:off x="0" y="73152"/>
+            <a:ext cx="12191695" cy="1051560"/>
+          </a:xfrm>
+          <a:prstGeom prst="rect">
+            <a:avLst/>
+          </a:prstGeom>
+          <a:solidFill>
+            <a:srgbClr val="FFFFFF"/>
+          </a:solidFill>
+          <a:ln w="12700">
+            <a:solidFill>
+              <a:srgbClr val="E2E8F0"/>
+            </a:solidFill>
+          </a:ln>
+        </p:spPr>
+        <p:style>
+          <a:lnRef idx="1">
+            <a:schemeClr val="accent1"/>
+          </a:lnRef>
+          <a:fillRef idx="3">
+            <a:schemeClr val="accent1"/>
+          </a:fillRef>
+          <a:effectRef idx="2">
+            <a:schemeClr val="accent1"/>
+          </a:effectRef>
+          <a:fontRef idx="minor">
+            <a:schemeClr val="lt1"/>
+          </a:fontRef>
+        </p:style>
+        <p:txBody>
+          <a:bodyPr rtlCol="0" anchor="ctr"/>
+          <a:lstStyle/>
+          <a:p>
+            <a:pPr algn="ctr"/>
+          </a:p>
+        </p:txBody>
+      </p:sp>
+      <p:sp>
+        <p:nvSpPr>
+          <p:cNvPr id="4" name="TextBox 3"/>
           <p:cNvSpPr txBox="1"/>
           <p:nvPr/>
         </p:nvSpPr>
         <p:spPr>
           <a:xfrm>
-            <a:off x="731520" y="228600"/>
-            <a:ext cx="7772400" cy="320040"/>
+            <a:off x="731520" y="164592"/>
+            <a:ext cx="7772400" cy="256032"/>
           </a:xfrm>
           <a:prstGeom prst="rect">
             <a:avLst/>
@@ -4190,20 +4452,20 @@
               </a:defRPr>
             </a:pPr>
             <a:r>
-              <a:t>CITIFLOW ESCROW | INSTITUTIONAL TRADE &amp; DVP</a:t>
-            </a:r>
-          </a:p>
-        </p:txBody>
-      </p:sp>
-      <p:sp>
-        <p:nvSpPr>
-          <p:cNvPr id="4" name="TextBox 3"/>
+              <a:t>CITIFLOW ESCROW | INSTITUTIONAL TRADE SETTLEMENT</a:t>
+            </a:r>
+          </a:p>
+        </p:txBody>
+      </p:sp>
+      <p:sp>
+        <p:nvSpPr>
+          <p:cNvPr id="5" name="TextBox 4"/>
           <p:cNvSpPr txBox="1"/>
           <p:nvPr/>
         </p:nvSpPr>
         <p:spPr>
           <a:xfrm>
-            <a:off x="731520" y="502920"/>
+            <a:off x="731520" y="438912"/>
             <a:ext cx="8686800" cy="594360"/>
           </a:xfrm>
           <a:prstGeom prst="rect">
@@ -4218,21 +4480,21 @@
           <a:lstStyle/>
           <a:p>
             <a:pPr>
-              <a:defRPr sz="2200" b="1">
+              <a:defRPr sz="2100" b="1">
                 <a:solidFill>
                   <a:srgbClr val="002D72"/>
                 </a:solidFill>
               </a:defRPr>
             </a:pPr>
             <a:r>
-              <a:t>The Solution: Unified Programmable Trade Settlement on Drunix</a:t>
+              <a:t>The Solution: Unified Programmable Trade Settlement on Drunix L1</a:t>
             </a:r>
           </a:p>
         </p:txBody>
       </p:sp>
       <p:pic>
         <p:nvPicPr>
-          <p:cNvPr id="5" name="Picture 4" descr="citi_logo.png"/>
+          <p:cNvPr id="6" name="Picture 5" descr="citi_logo.png"/>
           <p:cNvPicPr>
             <a:picLocks noChangeAspect="1"/>
           </p:cNvPicPr>
@@ -4246,8 +4508,8 @@
         </p:blipFill>
         <p:spPr>
           <a:xfrm>
-            <a:off x="10424160" y="292608"/>
-            <a:ext cx="1051560" cy="1051560"/>
+            <a:off x="10607040" y="292608"/>
+            <a:ext cx="960120" cy="960120"/>
           </a:xfrm>
           <a:prstGeom prst="rect">
             <a:avLst/>
@@ -4256,14 +4518,167 @@
       </p:pic>
       <p:sp>
         <p:nvSpPr>
-          <p:cNvPr id="6" name="Rounded Rectangle 5"/>
+          <p:cNvPr id="7" name="Rounded Rectangle 6"/>
           <p:cNvSpPr/>
           <p:nvPr/>
         </p:nvSpPr>
         <p:spPr>
           <a:xfrm>
-            <a:off x="731520" y="1371600"/>
-            <a:ext cx="2560320" cy="4754880"/>
+            <a:off x="777240" y="1353312"/>
+            <a:ext cx="2560320" cy="4846320"/>
+          </a:xfrm>
+          <a:prstGeom prst="roundRect">
+            <a:avLst/>
+          </a:prstGeom>
+          <a:solidFill>
+            <a:srgbClr val="FFFFFF"/>
+          </a:solidFill>
+          <a:ln w="15240">
+            <a:solidFill>
+              <a:srgbClr val="002D72"/>
+            </a:solidFill>
+          </a:ln>
+        </p:spPr>
+        <p:style>
+          <a:lnRef idx="1">
+            <a:schemeClr val="accent1"/>
+          </a:lnRef>
+          <a:fillRef idx="3">
+            <a:schemeClr val="accent1"/>
+          </a:fillRef>
+          <a:effectRef idx="2">
+            <a:schemeClr val="accent1"/>
+          </a:effectRef>
+          <a:fontRef idx="minor">
+            <a:schemeClr val="lt1"/>
+          </a:fontRef>
+        </p:style>
+        <p:txBody>
+          <a:bodyPr rtlCol="0" anchor="ctr"/>
+          <a:lstStyle/>
+          <a:p>
+            <a:pPr algn="ctr"/>
+          </a:p>
+        </p:txBody>
+      </p:sp>
+      <p:sp>
+        <p:nvSpPr>
+          <p:cNvPr id="8" name="Rectangle 7"/>
+          <p:cNvSpPr/>
+          <p:nvPr/>
+        </p:nvSpPr>
+        <p:spPr>
+          <a:xfrm>
+            <a:off x="777240" y="1353312"/>
+            <a:ext cx="2560320" cy="91440"/>
+          </a:xfrm>
+          <a:prstGeom prst="rect">
+            <a:avLst/>
+          </a:prstGeom>
+          <a:solidFill>
+            <a:srgbClr val="002D72"/>
+          </a:solidFill>
+          <a:ln>
+            <a:noFill/>
+          </a:ln>
+        </p:spPr>
+        <p:style>
+          <a:lnRef idx="1">
+            <a:schemeClr val="accent1"/>
+          </a:lnRef>
+          <a:fillRef idx="3">
+            <a:schemeClr val="accent1"/>
+          </a:fillRef>
+          <a:effectRef idx="2">
+            <a:schemeClr val="accent1"/>
+          </a:effectRef>
+          <a:fontRef idx="minor">
+            <a:schemeClr val="lt1"/>
+          </a:fontRef>
+        </p:style>
+        <p:txBody>
+          <a:bodyPr rtlCol="0" anchor="ctr"/>
+          <a:lstStyle/>
+          <a:p>
+            <a:pPr algn="ctr"/>
+          </a:p>
+        </p:txBody>
+      </p:sp>
+      <p:sp>
+        <p:nvSpPr>
+          <p:cNvPr id="9" name="TextBox 8"/>
+          <p:cNvSpPr txBox="1"/>
+          <p:nvPr/>
+        </p:nvSpPr>
+        <p:spPr>
+          <a:xfrm>
+            <a:off x="941832" y="1581912"/>
+            <a:ext cx="2231136" cy="4389120"/>
+          </a:xfrm>
+          <a:prstGeom prst="rect">
+            <a:avLst/>
+          </a:prstGeom>
+          <a:noFill/>
+        </p:spPr>
+        <p:txBody>
+          <a:bodyPr wrap="square">
+            <a:spAutoFit/>
+          </a:bodyPr>
+          <a:lstStyle/>
+          <a:p>
+            <a:pPr>
+              <a:defRPr sz="1550" b="1">
+                <a:solidFill>
+                  <a:srgbClr val="002D72"/>
+                </a:solidFill>
+              </a:defRPr>
+            </a:pPr>
+            <a:r>
+              <a:t>🔒 Smart Escrow Vault</a:t>
+            </a:r>
+          </a:p>
+          <a:p>
+            <a:pPr>
+              <a:spcBef>
+                <a:spcPts val="400"/>
+              </a:spcBef>
+              <a:defRPr sz="1100" b="1">
+                <a:solidFill>
+                  <a:srgbClr val="002D72"/>
+                </a:solidFill>
+              </a:defRPr>
+            </a:pPr>
+            <a:r>
+              <a:t>TradeEscrow.sol on Drunix</a:t>
+            </a:r>
+          </a:p>
+          <a:p>
+            <a:pPr>
+              <a:spcBef>
+                <a:spcPts val="1200"/>
+              </a:spcBef>
+              <a:defRPr sz="1100">
+                <a:solidFill>
+                  <a:srgbClr val="1E293B"/>
+                </a:solidFill>
+              </a:defRPr>
+            </a:pPr>
+            <a:r>
+              <a:t>Programmable tranche logic that locks capital upfront and releases tranches automatically upon multi-sig cryptographic oracle proofs rather than all-or-nothing payouts.</a:t>
+            </a:r>
+          </a:p>
+        </p:txBody>
+      </p:sp>
+      <p:sp>
+        <p:nvSpPr>
+          <p:cNvPr id="10" name="Rounded Rectangle 9"/>
+          <p:cNvSpPr/>
+          <p:nvPr/>
+        </p:nvSpPr>
+        <p:spPr>
+          <a:xfrm>
+            <a:off x="3474720" y="1353312"/>
+            <a:ext cx="2560320" cy="4846320"/>
           </a:xfrm>
           <a:prstGeom prst="roundRect">
             <a:avLst/>
@@ -4301,14 +4716,57 @@
       </p:sp>
       <p:sp>
         <p:nvSpPr>
-          <p:cNvPr id="7" name="TextBox 6"/>
+          <p:cNvPr id="11" name="Rectangle 10"/>
+          <p:cNvSpPr/>
+          <p:nvPr/>
+        </p:nvSpPr>
+        <p:spPr>
+          <a:xfrm>
+            <a:off x="3474720" y="1353312"/>
+            <a:ext cx="2560320" cy="91440"/>
+          </a:xfrm>
+          <a:prstGeom prst="rect">
+            <a:avLst/>
+          </a:prstGeom>
+          <a:solidFill>
+            <a:srgbClr val="056DAE"/>
+          </a:solidFill>
+          <a:ln>
+            <a:noFill/>
+          </a:ln>
+        </p:spPr>
+        <p:style>
+          <a:lnRef idx="1">
+            <a:schemeClr val="accent1"/>
+          </a:lnRef>
+          <a:fillRef idx="3">
+            <a:schemeClr val="accent1"/>
+          </a:fillRef>
+          <a:effectRef idx="2">
+            <a:schemeClr val="accent1"/>
+          </a:effectRef>
+          <a:fontRef idx="minor">
+            <a:schemeClr val="lt1"/>
+          </a:fontRef>
+        </p:style>
+        <p:txBody>
+          <a:bodyPr rtlCol="0" anchor="ctr"/>
+          <a:lstStyle/>
+          <a:p>
+            <a:pPr algn="ctr"/>
+          </a:p>
+        </p:txBody>
+      </p:sp>
+      <p:sp>
+        <p:nvSpPr>
+          <p:cNvPr id="12" name="TextBox 11"/>
           <p:cNvSpPr txBox="1"/>
           <p:nvPr/>
         </p:nvSpPr>
         <p:spPr>
           <a:xfrm>
-            <a:off x="896112" y="1600200"/>
-            <a:ext cx="2231136" cy="4297680"/>
+            <a:off x="3639312" y="1581912"/>
+            <a:ext cx="2231136" cy="4389120"/>
           </a:xfrm>
           <a:prstGeom prst="rect">
             <a:avLst/>
@@ -4322,14 +4780,14 @@
           <a:lstStyle/>
           <a:p>
             <a:pPr>
-              <a:defRPr sz="1500" b="1">
+              <a:defRPr sz="1550" b="1">
                 <a:solidFill>
                   <a:srgbClr val="002D72"/>
                 </a:solidFill>
               </a:defRPr>
             </a:pPr>
             <a:r>
-              <a:t>🔒 Smart Escrow Vault</a:t>
+              <a:t>📦 Tokenized RWA (e-BL)</a:t>
             </a:r>
           </a:p>
           <a:p>
@@ -4337,14 +4795,14 @@
               <a:spcBef>
                 <a:spcPts val="400"/>
               </a:spcBef>
-              <a:defRPr sz="1050" b="1">
+              <a:defRPr sz="1100" b="1">
                 <a:solidFill>
                   <a:srgbClr val="056DAE"/>
                 </a:solidFill>
               </a:defRPr>
             </a:pPr>
             <a:r>
-              <a:t>TradeEscrow.sol on Drunix</a:t>
+              <a:t>ERC-721 Digital Title</a:t>
             </a:r>
           </a:p>
           <a:p>
@@ -4354,26 +4812,26 @@
               </a:spcBef>
               <a:defRPr sz="1100">
                 <a:solidFill>
-                  <a:srgbClr val="212529"/>
-                </a:solidFill>
-              </a:defRPr>
-            </a:pPr>
-            <a:r>
-              <a:t>Programmable tranche logic that locks capital upfront and releases tranches only upon multi-sig cryptographic oracle proofs.</a:t>
-            </a:r>
-          </a:p>
-        </p:txBody>
-      </p:sp>
-      <p:sp>
-        <p:nvSpPr>
-          <p:cNvPr id="8" name="Rounded Rectangle 7"/>
+                  <a:srgbClr val="1E293B"/>
+                </a:solidFill>
+              </a:defRPr>
+            </a:pPr>
+            <a:r>
+              <a:t>Physical cargo consignment is minted on-chain as a digital Bill of Lading, securely locked in smart escrow, and transferred atomically upon payment completion (DvP).</a:t>
+            </a:r>
+          </a:p>
+        </p:txBody>
+      </p:sp>
+      <p:sp>
+        <p:nvSpPr>
+          <p:cNvPr id="13" name="Rounded Rectangle 12"/>
           <p:cNvSpPr/>
           <p:nvPr/>
         </p:nvSpPr>
         <p:spPr>
           <a:xfrm>
-            <a:off x="3429000" y="1371600"/>
-            <a:ext cx="2560320" cy="4754880"/>
+            <a:off x="6172200" y="1353312"/>
+            <a:ext cx="2560320" cy="4846320"/>
           </a:xfrm>
           <a:prstGeom prst="roundRect">
             <a:avLst/>
@@ -4383,7 +4841,7 @@
           </a:solidFill>
           <a:ln w="15240">
             <a:solidFill>
-              <a:srgbClr val="056DAE"/>
+              <a:srgbClr val="059669"/>
             </a:solidFill>
           </a:ln>
         </p:spPr>
@@ -4411,14 +4869,57 @@
       </p:sp>
       <p:sp>
         <p:nvSpPr>
-          <p:cNvPr id="9" name="TextBox 8"/>
+          <p:cNvPr id="14" name="Rectangle 13"/>
+          <p:cNvSpPr/>
+          <p:nvPr/>
+        </p:nvSpPr>
+        <p:spPr>
+          <a:xfrm>
+            <a:off x="6172200" y="1353312"/>
+            <a:ext cx="2560320" cy="91440"/>
+          </a:xfrm>
+          <a:prstGeom prst="rect">
+            <a:avLst/>
+          </a:prstGeom>
+          <a:solidFill>
+            <a:srgbClr val="059669"/>
+          </a:solidFill>
+          <a:ln>
+            <a:noFill/>
+          </a:ln>
+        </p:spPr>
+        <p:style>
+          <a:lnRef idx="1">
+            <a:schemeClr val="accent1"/>
+          </a:lnRef>
+          <a:fillRef idx="3">
+            <a:schemeClr val="accent1"/>
+          </a:fillRef>
+          <a:effectRef idx="2">
+            <a:schemeClr val="accent1"/>
+          </a:effectRef>
+          <a:fontRef idx="minor">
+            <a:schemeClr val="lt1"/>
+          </a:fontRef>
+        </p:style>
+        <p:txBody>
+          <a:bodyPr rtlCol="0" anchor="ctr"/>
+          <a:lstStyle/>
+          <a:p>
+            <a:pPr algn="ctr"/>
+          </a:p>
+        </p:txBody>
+      </p:sp>
+      <p:sp>
+        <p:nvSpPr>
+          <p:cNvPr id="15" name="TextBox 14"/>
           <p:cNvSpPr txBox="1"/>
           <p:nvPr/>
         </p:nvSpPr>
         <p:spPr>
           <a:xfrm>
-            <a:off x="3593592" y="1600200"/>
-            <a:ext cx="2231136" cy="4297680"/>
+            <a:off x="6336792" y="1581912"/>
+            <a:ext cx="2231136" cy="4389120"/>
           </a:xfrm>
           <a:prstGeom prst="rect">
             <a:avLst/>
@@ -4432,14 +4933,14 @@
           <a:lstStyle/>
           <a:p>
             <a:pPr>
-              <a:defRPr sz="1500" b="1">
+              <a:defRPr sz="1550" b="1">
                 <a:solidFill>
                   <a:srgbClr val="002D72"/>
                 </a:solidFill>
               </a:defRPr>
             </a:pPr>
             <a:r>
-              <a:t>📦 Tokenized RWA (e-BL)</a:t>
+              <a:t>📡 Real-Time Oracles</a:t>
             </a:r>
           </a:p>
           <a:p>
@@ -4447,14 +4948,14 @@
               <a:spcBef>
                 <a:spcPts val="400"/>
               </a:spcBef>
-              <a:defRPr sz="1050" b="1">
-                <a:solidFill>
-                  <a:srgbClr val="056DAE"/>
-                </a:solidFill>
-              </a:defRPr>
-            </a:pPr>
-            <a:r>
-              <a:t>ERC-721 Digital Title</a:t>
+              <a:defRPr sz="1100" b="1">
+                <a:solidFill>
+                  <a:srgbClr val="059669"/>
+                </a:solidFill>
+              </a:defRPr>
+            </a:pPr>
+            <a:r>
+              <a:t>ICEGATE &amp; Telemetry Feeds</a:t>
             </a:r>
           </a:p>
           <a:p>
@@ -4464,26 +4965,26 @@
               </a:spcBef>
               <a:defRPr sz="1100">
                 <a:solidFill>
-                  <a:srgbClr val="212529"/>
-                </a:solidFill>
-              </a:defRPr>
-            </a:pPr>
-            <a:r>
-              <a:t>Cargo consignment is minted on-chain as a digital Bill of Lading, held in escrow, and transferred atomically upon payment (DvP).</a:t>
-            </a:r>
-          </a:p>
-        </p:txBody>
-      </p:sp>
-      <p:sp>
-        <p:nvSpPr>
-          <p:cNvPr id="10" name="Rounded Rectangle 9"/>
+                  <a:srgbClr val="1E293B"/>
+                </a:solidFill>
+              </a:defRPr>
+            </a:pPr>
+            <a:r>
+              <a:t>Direct automated cryptographic attestation of TÜV SÜD factory inspection, MSC shipping carrier vessel GPS, and Indian Customs ICEGATE Out-of-Charge (OOC).</a:t>
+            </a:r>
+          </a:p>
+        </p:txBody>
+      </p:sp>
+      <p:sp>
+        <p:nvSpPr>
+          <p:cNvPr id="16" name="Rounded Rectangle 15"/>
           <p:cNvSpPr/>
           <p:nvPr/>
         </p:nvSpPr>
         <p:spPr>
           <a:xfrm>
-            <a:off x="6126480" y="1371600"/>
-            <a:ext cx="2560320" cy="4754880"/>
+            <a:off x="8869680" y="1353312"/>
+            <a:ext cx="2560320" cy="4846320"/>
           </a:xfrm>
           <a:prstGeom prst="roundRect">
             <a:avLst/>
@@ -4493,7 +4994,7 @@
           </a:solidFill>
           <a:ln w="15240">
             <a:solidFill>
-              <a:srgbClr val="056DAE"/>
+              <a:srgbClr val="D97706"/>
             </a:solidFill>
           </a:ln>
         </p:spPr>
@@ -4521,14 +5022,57 @@
       </p:sp>
       <p:sp>
         <p:nvSpPr>
-          <p:cNvPr id="11" name="TextBox 10"/>
+          <p:cNvPr id="17" name="Rectangle 16"/>
+          <p:cNvSpPr/>
+          <p:nvPr/>
+        </p:nvSpPr>
+        <p:spPr>
+          <a:xfrm>
+            <a:off x="8869680" y="1353312"/>
+            <a:ext cx="2560320" cy="91440"/>
+          </a:xfrm>
+          <a:prstGeom prst="rect">
+            <a:avLst/>
+          </a:prstGeom>
+          <a:solidFill>
+            <a:srgbClr val="D97706"/>
+          </a:solidFill>
+          <a:ln>
+            <a:noFill/>
+          </a:ln>
+        </p:spPr>
+        <p:style>
+          <a:lnRef idx="1">
+            <a:schemeClr val="accent1"/>
+          </a:lnRef>
+          <a:fillRef idx="3">
+            <a:schemeClr val="accent1"/>
+          </a:fillRef>
+          <a:effectRef idx="2">
+            <a:schemeClr val="accent1"/>
+          </a:effectRef>
+          <a:fontRef idx="minor">
+            <a:schemeClr val="lt1"/>
+          </a:fontRef>
+        </p:style>
+        <p:txBody>
+          <a:bodyPr rtlCol="0" anchor="ctr"/>
+          <a:lstStyle/>
+          <a:p>
+            <a:pPr algn="ctr"/>
+          </a:p>
+        </p:txBody>
+      </p:sp>
+      <p:sp>
+        <p:nvSpPr>
+          <p:cNvPr id="18" name="TextBox 17"/>
           <p:cNvSpPr txBox="1"/>
           <p:nvPr/>
         </p:nvSpPr>
         <p:spPr>
           <a:xfrm>
-            <a:off x="6291072" y="1600200"/>
-            <a:ext cx="2231136" cy="4297680"/>
+            <a:off x="9034272" y="1581912"/>
+            <a:ext cx="2231136" cy="4389120"/>
           </a:xfrm>
           <a:prstGeom prst="rect">
             <a:avLst/>
@@ -4542,14 +5086,14 @@
           <a:lstStyle/>
           <a:p>
             <a:pPr>
-              <a:defRPr sz="1500" b="1">
+              <a:defRPr sz="1550" b="1">
                 <a:solidFill>
                   <a:srgbClr val="002D72"/>
                 </a:solidFill>
               </a:defRPr>
             </a:pPr>
             <a:r>
-              <a:t>📡 Real-Time Oracles</a:t>
+              <a:t>🏦 Dual Settlement Rails</a:t>
             </a:r>
           </a:p>
           <a:p>
@@ -4557,14 +5101,14 @@
               <a:spcBef>
                 <a:spcPts val="400"/>
               </a:spcBef>
-              <a:defRPr sz="1050" b="1">
-                <a:solidFill>
-                  <a:srgbClr val="056DAE"/>
-                </a:solidFill>
-              </a:defRPr>
-            </a:pPr>
-            <a:r>
-              <a:t>ICEGATE &amp; Telemetry Feeds</a:t>
+              <a:defRPr sz="1100" b="1">
+                <a:solidFill>
+                  <a:srgbClr val="D97706"/>
+                </a:solidFill>
+              </a:defRPr>
+            </a:pPr>
+            <a:r>
+              <a:t>Citi ISO 20022 + NPCI</a:t>
             </a:r>
           </a:p>
           <a:p>
@@ -4574,122 +5118,12 @@
               </a:spcBef>
               <a:defRPr sz="1100">
                 <a:solidFill>
-                  <a:srgbClr val="212529"/>
-                </a:solidFill>
-              </a:defRPr>
-            </a:pPr>
-            <a:r>
-              <a:t>Direct automated verification of TÜV SÜD factory inspection, MSC shipping carrier vessel GPS, and Indian Customs Out-of-Charge.</a:t>
-            </a:r>
-          </a:p>
-        </p:txBody>
-      </p:sp>
-      <p:sp>
-        <p:nvSpPr>
-          <p:cNvPr id="12" name="Rounded Rectangle 11"/>
-          <p:cNvSpPr/>
-          <p:nvPr/>
-        </p:nvSpPr>
-        <p:spPr>
-          <a:xfrm>
-            <a:off x="8823960" y="1371600"/>
-            <a:ext cx="2560320" cy="4754880"/>
-          </a:xfrm>
-          <a:prstGeom prst="roundRect">
-            <a:avLst/>
-          </a:prstGeom>
-          <a:solidFill>
-            <a:srgbClr val="FFFFFF"/>
-          </a:solidFill>
-          <a:ln w="15240">
-            <a:solidFill>
-              <a:srgbClr val="056DAE"/>
-            </a:solidFill>
-          </a:ln>
-        </p:spPr>
-        <p:style>
-          <a:lnRef idx="1">
-            <a:schemeClr val="accent1"/>
-          </a:lnRef>
-          <a:fillRef idx="3">
-            <a:schemeClr val="accent1"/>
-          </a:fillRef>
-          <a:effectRef idx="2">
-            <a:schemeClr val="accent1"/>
-          </a:effectRef>
-          <a:fontRef idx="minor">
-            <a:schemeClr val="lt1"/>
-          </a:fontRef>
-        </p:style>
-        <p:txBody>
-          <a:bodyPr rtlCol="0" anchor="ctr"/>
-          <a:lstStyle/>
-          <a:p>
-            <a:pPr algn="ctr"/>
-          </a:p>
-        </p:txBody>
-      </p:sp>
-      <p:sp>
-        <p:nvSpPr>
-          <p:cNvPr id="13" name="TextBox 12"/>
-          <p:cNvSpPr txBox="1"/>
-          <p:nvPr/>
-        </p:nvSpPr>
-        <p:spPr>
-          <a:xfrm>
-            <a:off x="8988552" y="1600200"/>
-            <a:ext cx="2231136" cy="4297680"/>
-          </a:xfrm>
-          <a:prstGeom prst="rect">
-            <a:avLst/>
-          </a:prstGeom>
-          <a:noFill/>
-        </p:spPr>
-        <p:txBody>
-          <a:bodyPr wrap="square">
-            <a:spAutoFit/>
-          </a:bodyPr>
-          <a:lstStyle/>
-          <a:p>
-            <a:pPr>
-              <a:defRPr sz="1500" b="1">
-                <a:solidFill>
-                  <a:srgbClr val="002D72"/>
-                </a:solidFill>
-              </a:defRPr>
-            </a:pPr>
-            <a:r>
-              <a:t>🏦 Dual Settlement Rails</a:t>
-            </a:r>
-          </a:p>
-          <a:p>
-            <a:pPr>
-              <a:spcBef>
-                <a:spcPts val="400"/>
-              </a:spcBef>
-              <a:defRPr sz="1050" b="1">
-                <a:solidFill>
-                  <a:srgbClr val="056DAE"/>
-                </a:solidFill>
-              </a:defRPr>
-            </a:pPr>
-            <a:r>
-              <a:t>Citi ISO 20022 + NPCI</a:t>
-            </a:r>
-          </a:p>
-          <a:p>
-            <a:pPr>
-              <a:spcBef>
-                <a:spcPts val="1200"/>
-              </a:spcBef>
-              <a:defRPr sz="1100">
-                <a:solidFill>
-                  <a:srgbClr val="212529"/>
-                </a:solidFill>
-              </a:defRPr>
-            </a:pPr>
-            <a:r>
-              <a:t>Institutional cross-border wires via pacs.008 XML &amp; live FX hedging combined with 1-click UPI 2.0 &amp; e-RUPI vouchers.</a:t>
+                  <a:srgbClr val="1E293B"/>
+                </a:solidFill>
+              </a:defRPr>
+            </a:pPr>
+            <a:r>
+              <a:t>Institutional cross-border wires via pacs.008 XML &amp; live Spot FX hedging combined with 1-click sovereign UPI 2.0 &amp; purpose-bound e-RUPI vouchers.</a:t>
             </a:r>
           </a:p>
         </p:txBody>
@@ -4757,14 +5191,59 @@
       </p:sp>
       <p:sp>
         <p:nvSpPr>
-          <p:cNvPr id="3" name="TextBox 2"/>
+          <p:cNvPr id="3" name="Rectangle 2"/>
+          <p:cNvSpPr/>
+          <p:nvPr/>
+        </p:nvSpPr>
+        <p:spPr>
+          <a:xfrm>
+            <a:off x="0" y="73152"/>
+            <a:ext cx="12191695" cy="1051560"/>
+          </a:xfrm>
+          <a:prstGeom prst="rect">
+            <a:avLst/>
+          </a:prstGeom>
+          <a:solidFill>
+            <a:srgbClr val="FFFFFF"/>
+          </a:solidFill>
+          <a:ln w="12700">
+            <a:solidFill>
+              <a:srgbClr val="E2E8F0"/>
+            </a:solidFill>
+          </a:ln>
+        </p:spPr>
+        <p:style>
+          <a:lnRef idx="1">
+            <a:schemeClr val="accent1"/>
+          </a:lnRef>
+          <a:fillRef idx="3">
+            <a:schemeClr val="accent1"/>
+          </a:fillRef>
+          <a:effectRef idx="2">
+            <a:schemeClr val="accent1"/>
+          </a:effectRef>
+          <a:fontRef idx="minor">
+            <a:schemeClr val="lt1"/>
+          </a:fontRef>
+        </p:style>
+        <p:txBody>
+          <a:bodyPr rtlCol="0" anchor="ctr"/>
+          <a:lstStyle/>
+          <a:p>
+            <a:pPr algn="ctr"/>
+          </a:p>
+        </p:txBody>
+      </p:sp>
+      <p:sp>
+        <p:nvSpPr>
+          <p:cNvPr id="4" name="TextBox 3"/>
           <p:cNvSpPr txBox="1"/>
           <p:nvPr/>
         </p:nvSpPr>
         <p:spPr>
           <a:xfrm>
-            <a:off x="731520" y="228600"/>
-            <a:ext cx="7772400" cy="320040"/>
+            <a:off x="731520" y="164592"/>
+            <a:ext cx="7772400" cy="256032"/>
           </a:xfrm>
           <a:prstGeom prst="rect">
             <a:avLst/>
@@ -4785,20 +5264,20 @@
               </a:defRPr>
             </a:pPr>
             <a:r>
-              <a:t>CITIFLOW ESCROW | INSTITUTIONAL TRADE &amp; DVP</a:t>
-            </a:r>
-          </a:p>
-        </p:txBody>
-      </p:sp>
-      <p:sp>
-        <p:nvSpPr>
-          <p:cNvPr id="4" name="TextBox 3"/>
+              <a:t>CITIFLOW ESCROW | INSTITUTIONAL TRADE SETTLEMENT</a:t>
+            </a:r>
+          </a:p>
+        </p:txBody>
+      </p:sp>
+      <p:sp>
+        <p:nvSpPr>
+          <p:cNvPr id="5" name="TextBox 4"/>
           <p:cNvSpPr txBox="1"/>
           <p:nvPr/>
         </p:nvSpPr>
         <p:spPr>
           <a:xfrm>
-            <a:off x="731520" y="502920"/>
+            <a:off x="731520" y="438912"/>
             <a:ext cx="8686800" cy="594360"/>
           </a:xfrm>
           <a:prstGeom prst="rect">
@@ -4813,7 +5292,7 @@
           <a:lstStyle/>
           <a:p>
             <a:pPr>
-              <a:defRPr sz="2200" b="1">
+              <a:defRPr sz="2100" b="1">
                 <a:solidFill>
                   <a:srgbClr val="002D72"/>
                 </a:solidFill>
@@ -4827,7 +5306,7 @@
       </p:sp>
       <p:pic>
         <p:nvPicPr>
-          <p:cNvPr id="5" name="Picture 4" descr="citi_logo.png"/>
+          <p:cNvPr id="6" name="Picture 5" descr="citi_logo.png"/>
           <p:cNvPicPr>
             <a:picLocks noChangeAspect="1"/>
           </p:cNvPicPr>
@@ -4841,8 +5320,8 @@
         </p:blipFill>
         <p:spPr>
           <a:xfrm>
-            <a:off x="10424160" y="292608"/>
-            <a:ext cx="1051560" cy="1051560"/>
+            <a:off x="10607040" y="292608"/>
+            <a:ext cx="960120" cy="960120"/>
           </a:xfrm>
           <a:prstGeom prst="rect">
             <a:avLst/>
@@ -4851,14 +5330,14 @@
       </p:pic>
       <p:sp>
         <p:nvSpPr>
-          <p:cNvPr id="6" name="Rounded Rectangle 5"/>
+          <p:cNvPr id="7" name="Rounded Rectangle 6"/>
           <p:cNvSpPr/>
           <p:nvPr/>
         </p:nvSpPr>
         <p:spPr>
           <a:xfrm>
-            <a:off x="731520" y="1371600"/>
-            <a:ext cx="2560320" cy="4754880"/>
+            <a:off x="777240" y="1353312"/>
+            <a:ext cx="2560320" cy="4846320"/>
           </a:xfrm>
           <a:prstGeom prst="roundRect">
             <a:avLst/>
@@ -4868,7 +5347,7 @@
           </a:solidFill>
           <a:ln w="15240">
             <a:solidFill>
-              <a:srgbClr val="E2E8F0"/>
+              <a:srgbClr val="056DAE"/>
             </a:solidFill>
           </a:ln>
         </p:spPr>
@@ -4896,14 +5375,191 @@
       </p:sp>
       <p:sp>
         <p:nvSpPr>
-          <p:cNvPr id="7" name="Oval 6"/>
+          <p:cNvPr id="8" name="Oval 7"/>
           <p:cNvSpPr/>
           <p:nvPr/>
         </p:nvSpPr>
         <p:spPr>
           <a:xfrm>
-            <a:off x="914400" y="1600200"/>
-            <a:ext cx="502920" cy="502920"/>
+            <a:off x="960120" y="1554480"/>
+            <a:ext cx="530352" cy="530352"/>
+          </a:xfrm>
+          <a:prstGeom prst="ellipse">
+            <a:avLst/>
+          </a:prstGeom>
+          <a:solidFill>
+            <a:srgbClr val="056DAE"/>
+          </a:solidFill>
+          <a:ln>
+            <a:noFill/>
+          </a:ln>
+        </p:spPr>
+        <p:style>
+          <a:lnRef idx="1">
+            <a:schemeClr val="accent1"/>
+          </a:lnRef>
+          <a:fillRef idx="3">
+            <a:schemeClr val="accent1"/>
+          </a:fillRef>
+          <a:effectRef idx="2">
+            <a:schemeClr val="accent1"/>
+          </a:effectRef>
+          <a:fontRef idx="minor">
+            <a:schemeClr val="lt1"/>
+          </a:fontRef>
+        </p:style>
+        <p:txBody>
+          <a:bodyPr rtlCol="0" anchor="ctr"/>
+          <a:lstStyle/>
+          <a:p>
+            <a:pPr algn="ctr">
+              <a:defRPr sz="1400" b="1">
+                <a:solidFill>
+                  <a:srgbClr val="FFFFFF"/>
+                </a:solidFill>
+              </a:defRPr>
+            </a:pPr>
+            <a:r>
+              <a:t>1</a:t>
+            </a:r>
+          </a:p>
+        </p:txBody>
+      </p:sp>
+      <p:sp>
+        <p:nvSpPr>
+          <p:cNvPr id="9" name="TextBox 8"/>
+          <p:cNvSpPr txBox="1"/>
+          <p:nvPr/>
+        </p:nvSpPr>
+        <p:spPr>
+          <a:xfrm>
+            <a:off x="941832" y="2176272"/>
+            <a:ext cx="2231136" cy="3840480"/>
+          </a:xfrm>
+          <a:prstGeom prst="rect">
+            <a:avLst/>
+          </a:prstGeom>
+          <a:noFill/>
+        </p:spPr>
+        <p:txBody>
+          <a:bodyPr wrap="square">
+            <a:spAutoFit/>
+          </a:bodyPr>
+          <a:lstStyle/>
+          <a:p>
+            <a:pPr>
+              <a:defRPr sz="1450" b="1">
+                <a:solidFill>
+                  <a:srgbClr val="002D72"/>
+                </a:solidFill>
+              </a:defRPr>
+            </a:pPr>
+            <a:r>
+              <a:t>Stage 1: 20% Advance</a:t>
+            </a:r>
+          </a:p>
+          <a:p>
+            <a:pPr>
+              <a:spcBef>
+                <a:spcPts val="300"/>
+              </a:spcBef>
+              <a:defRPr sz="1100" b="1">
+                <a:solidFill>
+                  <a:srgbClr val="056DAE"/>
+                </a:solidFill>
+              </a:defRPr>
+            </a:pPr>
+            <a:r>
+              <a:t>Factory Acceptance (FAT)</a:t>
+            </a:r>
+          </a:p>
+          <a:p>
+            <a:pPr>
+              <a:spcBef>
+                <a:spcPts val="800"/>
+              </a:spcBef>
+              <a:defRPr sz="1050">
+                <a:solidFill>
+                  <a:srgbClr val="1E293B"/>
+                </a:solidFill>
+              </a:defRPr>
+            </a:pPr>
+            <a:r>
+              <a:t>TÜV SÜD audit certificate verified on Drunix ledger. Advance liquidity disbursed to supplier for raw material kickoff.</a:t>
+            </a:r>
+          </a:p>
+          <a:p>
+            <a:pPr>
+              <a:spcBef>
+                <a:spcPts val="1000"/>
+              </a:spcBef>
+              <a:defRPr sz="950" b="1">
+                <a:solidFill>
+                  <a:srgbClr val="056DAE"/>
+                </a:solidFill>
+              </a:defRPr>
+            </a:pPr>
+            <a:r>
+              <a:t>⚡ Trigger: TÜV SÜD Audit Hash</a:t>
+            </a:r>
+          </a:p>
+        </p:txBody>
+      </p:sp>
+      <p:sp>
+        <p:nvSpPr>
+          <p:cNvPr id="10" name="Rounded Rectangle 9"/>
+          <p:cNvSpPr/>
+          <p:nvPr/>
+        </p:nvSpPr>
+        <p:spPr>
+          <a:xfrm>
+            <a:off x="3474720" y="1353312"/>
+            <a:ext cx="2560320" cy="4846320"/>
+          </a:xfrm>
+          <a:prstGeom prst="roundRect">
+            <a:avLst/>
+          </a:prstGeom>
+          <a:solidFill>
+            <a:srgbClr val="FFFFFF"/>
+          </a:solidFill>
+          <a:ln w="15240">
+            <a:solidFill>
+              <a:srgbClr val="002D72"/>
+            </a:solidFill>
+          </a:ln>
+        </p:spPr>
+        <p:style>
+          <a:lnRef idx="1">
+            <a:schemeClr val="accent1"/>
+          </a:lnRef>
+          <a:fillRef idx="3">
+            <a:schemeClr val="accent1"/>
+          </a:fillRef>
+          <a:effectRef idx="2">
+            <a:schemeClr val="accent1"/>
+          </a:effectRef>
+          <a:fontRef idx="minor">
+            <a:schemeClr val="lt1"/>
+          </a:fontRef>
+        </p:style>
+        <p:txBody>
+          <a:bodyPr rtlCol="0" anchor="ctr"/>
+          <a:lstStyle/>
+          <a:p>
+            <a:pPr algn="ctr"/>
+          </a:p>
+        </p:txBody>
+      </p:sp>
+      <p:sp>
+        <p:nvSpPr>
+          <p:cNvPr id="11" name="Oval 10"/>
+          <p:cNvSpPr/>
+          <p:nvPr/>
+        </p:nvSpPr>
+        <p:spPr>
+          <a:xfrm>
+            <a:off x="3657600" y="1554480"/>
+            <a:ext cx="530352" cy="530352"/>
           </a:xfrm>
           <a:prstGeom prst="ellipse">
             <a:avLst/>
@@ -4941,21 +5597,21 @@
               </a:defRPr>
             </a:pPr>
             <a:r>
-              <a:t>1</a:t>
-            </a:r>
-          </a:p>
-        </p:txBody>
-      </p:sp>
-      <p:sp>
-        <p:nvSpPr>
-          <p:cNvPr id="8" name="TextBox 7"/>
+              <a:t>2</a:t>
+            </a:r>
+          </a:p>
+        </p:txBody>
+      </p:sp>
+      <p:sp>
+        <p:nvSpPr>
+          <p:cNvPr id="12" name="TextBox 11"/>
           <p:cNvSpPr txBox="1"/>
           <p:nvPr/>
         </p:nvSpPr>
         <p:spPr>
           <a:xfrm>
-            <a:off x="896112" y="2194560"/>
-            <a:ext cx="2231136" cy="3657600"/>
+            <a:off x="3639312" y="2176272"/>
+            <a:ext cx="2231136" cy="3840480"/>
           </a:xfrm>
           <a:prstGeom prst="rect">
             <a:avLst/>
@@ -4969,29 +5625,44 @@
           <a:lstStyle/>
           <a:p>
             <a:pPr>
-              <a:defRPr sz="1400" b="1">
+              <a:defRPr sz="1450" b="1">
                 <a:solidFill>
                   <a:srgbClr val="002D72"/>
                 </a:solidFill>
               </a:defRPr>
             </a:pPr>
             <a:r>
-              <a:t>Stage 1: 20% Advance</a:t>
+              <a:t>Stage 2: 30% Departure</a:t>
             </a:r>
           </a:p>
           <a:p>
             <a:pPr>
               <a:spcBef>
-                <a:spcPts val="400"/>
+                <a:spcPts val="300"/>
               </a:spcBef>
-              <a:defRPr sz="1050" b="1">
-                <a:solidFill>
-                  <a:srgbClr val="056DAE"/>
-                </a:solidFill>
-              </a:defRPr>
-            </a:pPr>
-            <a:r>
-              <a:t>Factory Acceptance Test (FAT)</a:t>
+              <a:defRPr sz="1100" b="1">
+                <a:solidFill>
+                  <a:srgbClr val="002D72"/>
+                </a:solidFill>
+              </a:defRPr>
+            </a:pPr>
+            <a:r>
+              <a:t>Origin Port Loading &amp; e-BL</a:t>
+            </a:r>
+          </a:p>
+          <a:p>
+            <a:pPr>
+              <a:spcBef>
+                <a:spcPts val="800"/>
+              </a:spcBef>
+              <a:defRPr sz="1050">
+                <a:solidFill>
+                  <a:srgbClr val="1E293B"/>
+                </a:solidFill>
+              </a:defRPr>
+            </a:pPr>
+            <a:r>
+              <a:t>Vessel carrier (MSC) confirms container on board. Digital e-Bill of Lading NFT is minted and locked in smart escrow.</a:t>
             </a:r>
           </a:p>
           <a:p>
@@ -4999,28 +5670,28 @@
               <a:spcBef>
                 <a:spcPts val="1000"/>
               </a:spcBef>
-              <a:defRPr sz="1100">
-                <a:solidFill>
-                  <a:srgbClr val="212529"/>
-                </a:solidFill>
-              </a:defRPr>
-            </a:pPr>
-            <a:r>
-              <a:t>TÜV SÜD audit certificate verified on Drunix ledger. Advance liquidity released to supplier for raw material kickoff.</a:t>
-            </a:r>
-          </a:p>
-        </p:txBody>
-      </p:sp>
-      <p:sp>
-        <p:nvSpPr>
-          <p:cNvPr id="9" name="Rounded Rectangle 8"/>
+              <a:defRPr sz="950" b="1">
+                <a:solidFill>
+                  <a:srgbClr val="056DAE"/>
+                </a:solidFill>
+              </a:defRPr>
+            </a:pPr>
+            <a:r>
+              <a:t>⚡ Trigger: Carrier AIS Departure</a:t>
+            </a:r>
+          </a:p>
+        </p:txBody>
+      </p:sp>
+      <p:sp>
+        <p:nvSpPr>
+          <p:cNvPr id="13" name="Rounded Rectangle 12"/>
           <p:cNvSpPr/>
           <p:nvPr/>
         </p:nvSpPr>
         <p:spPr>
           <a:xfrm>
-            <a:off x="3429000" y="1371600"/>
-            <a:ext cx="2560320" cy="4754880"/>
+            <a:off x="6172200" y="1353312"/>
+            <a:ext cx="2560320" cy="4846320"/>
           </a:xfrm>
           <a:prstGeom prst="roundRect">
             <a:avLst/>
@@ -5030,7 +5701,7 @@
           </a:solidFill>
           <a:ln w="15240">
             <a:solidFill>
-              <a:srgbClr val="E2E8F0"/>
+              <a:srgbClr val="D97706"/>
             </a:solidFill>
           </a:ln>
         </p:spPr>
@@ -5058,20 +5729,20 @@
       </p:sp>
       <p:sp>
         <p:nvSpPr>
-          <p:cNvPr id="10" name="Oval 9"/>
+          <p:cNvPr id="14" name="Oval 13"/>
           <p:cNvSpPr/>
           <p:nvPr/>
         </p:nvSpPr>
         <p:spPr>
           <a:xfrm>
-            <a:off x="3611880" y="1600200"/>
-            <a:ext cx="502920" cy="502920"/>
+            <a:off x="6355080" y="1554480"/>
+            <a:ext cx="530352" cy="530352"/>
           </a:xfrm>
           <a:prstGeom prst="ellipse">
             <a:avLst/>
           </a:prstGeom>
           <a:solidFill>
-            <a:srgbClr val="002D72"/>
+            <a:srgbClr val="D97706"/>
           </a:solidFill>
           <a:ln>
             <a:noFill/>
@@ -5103,21 +5774,21 @@
               </a:defRPr>
             </a:pPr>
             <a:r>
-              <a:t>2</a:t>
-            </a:r>
-          </a:p>
-        </p:txBody>
-      </p:sp>
-      <p:sp>
-        <p:nvSpPr>
-          <p:cNvPr id="11" name="TextBox 10"/>
+              <a:t>3</a:t>
+            </a:r>
+          </a:p>
+        </p:txBody>
+      </p:sp>
+      <p:sp>
+        <p:nvSpPr>
+          <p:cNvPr id="15" name="TextBox 14"/>
           <p:cNvSpPr txBox="1"/>
           <p:nvPr/>
         </p:nvSpPr>
         <p:spPr>
           <a:xfrm>
-            <a:off x="3593592" y="2194560"/>
-            <a:ext cx="2231136" cy="3657600"/>
+            <a:off x="6336792" y="2176272"/>
+            <a:ext cx="2231136" cy="3840480"/>
           </a:xfrm>
           <a:prstGeom prst="rect">
             <a:avLst/>
@@ -5131,29 +5802,44 @@
           <a:lstStyle/>
           <a:p>
             <a:pPr>
-              <a:defRPr sz="1400" b="1">
+              <a:defRPr sz="1450" b="1">
                 <a:solidFill>
                   <a:srgbClr val="002D72"/>
                 </a:solidFill>
               </a:defRPr>
             </a:pPr>
             <a:r>
-              <a:t>Stage 2: 30% Departure</a:t>
+              <a:t>Stage 3: 30% Customs</a:t>
             </a:r>
           </a:p>
           <a:p>
             <a:pPr>
               <a:spcBef>
-                <a:spcPts val="400"/>
+                <a:spcPts val="300"/>
               </a:spcBef>
-              <a:defRPr sz="1050" b="1">
-                <a:solidFill>
-                  <a:srgbClr val="056DAE"/>
-                </a:solidFill>
-              </a:defRPr>
-            </a:pPr>
-            <a:r>
-              <a:t>Origin Port Loading &amp; e-BL</a:t>
+              <a:defRPr sz="1100" b="1">
+                <a:solidFill>
+                  <a:srgbClr val="D97706"/>
+                </a:solidFill>
+              </a:defRPr>
+            </a:pPr>
+            <a:r>
+              <a:t>ICEGATE Customs Clearance</a:t>
+            </a:r>
+          </a:p>
+          <a:p>
+            <a:pPr>
+              <a:spcBef>
+                <a:spcPts val="800"/>
+              </a:spcBef>
+              <a:defRPr sz="1050">
+                <a:solidFill>
+                  <a:srgbClr val="1E293B"/>
+                </a:solidFill>
+              </a:defRPr>
+            </a:pPr>
+            <a:r>
+              <a:t>Indian Customs duty verified at Nhava Sheva (JNPT). Funds disbursed &amp; purpose-bound e-RUPI vouchers issued for port handling.</a:t>
             </a:r>
           </a:p>
           <a:p>
@@ -5161,28 +5847,28 @@
               <a:spcBef>
                 <a:spcPts val="1000"/>
               </a:spcBef>
-              <a:defRPr sz="1100">
-                <a:solidFill>
-                  <a:srgbClr val="212529"/>
-                </a:solidFill>
-              </a:defRPr>
-            </a:pPr>
-            <a:r>
-              <a:t>Vessel carrier (MSC) confirms container on board. Digital e-Bill of Lading NFT is minted and locked in smart escrow.</a:t>
-            </a:r>
-          </a:p>
-        </p:txBody>
-      </p:sp>
-      <p:sp>
-        <p:nvSpPr>
-          <p:cNvPr id="12" name="Rounded Rectangle 11"/>
+              <a:defRPr sz="950" b="1">
+                <a:solidFill>
+                  <a:srgbClr val="056DAE"/>
+                </a:solidFill>
+              </a:defRPr>
+            </a:pPr>
+            <a:r>
+              <a:t>⚡ Trigger: ICEGATE OOC Granted</a:t>
+            </a:r>
+          </a:p>
+        </p:txBody>
+      </p:sp>
+      <p:sp>
+        <p:nvSpPr>
+          <p:cNvPr id="16" name="Rounded Rectangle 15"/>
           <p:cNvSpPr/>
           <p:nvPr/>
         </p:nvSpPr>
         <p:spPr>
           <a:xfrm>
-            <a:off x="6126480" y="1371600"/>
-            <a:ext cx="2560320" cy="4754880"/>
+            <a:off x="8869680" y="1353312"/>
+            <a:ext cx="2560320" cy="4846320"/>
           </a:xfrm>
           <a:prstGeom prst="roundRect">
             <a:avLst/>
@@ -5192,7 +5878,7 @@
           </a:solidFill>
           <a:ln w="15240">
             <a:solidFill>
-              <a:srgbClr val="E2E8F0"/>
+              <a:srgbClr val="059669"/>
             </a:solidFill>
           </a:ln>
         </p:spPr>
@@ -5220,20 +5906,20 @@
       </p:sp>
       <p:sp>
         <p:nvSpPr>
-          <p:cNvPr id="13" name="Oval 12"/>
+          <p:cNvPr id="17" name="Oval 16"/>
           <p:cNvSpPr/>
           <p:nvPr/>
         </p:nvSpPr>
         <p:spPr>
           <a:xfrm>
-            <a:off x="6309360" y="1600200"/>
-            <a:ext cx="502920" cy="502920"/>
+            <a:off x="9052560" y="1554480"/>
+            <a:ext cx="530352" cy="530352"/>
           </a:xfrm>
           <a:prstGeom prst="ellipse">
             <a:avLst/>
           </a:prstGeom>
           <a:solidFill>
-            <a:srgbClr val="002D72"/>
+            <a:srgbClr val="059669"/>
           </a:solidFill>
           <a:ln>
             <a:noFill/>
@@ -5265,21 +5951,21 @@
               </a:defRPr>
             </a:pPr>
             <a:r>
-              <a:t>3</a:t>
-            </a:r>
-          </a:p>
-        </p:txBody>
-      </p:sp>
-      <p:sp>
-        <p:nvSpPr>
-          <p:cNvPr id="14" name="TextBox 13"/>
+              <a:t>4</a:t>
+            </a:r>
+          </a:p>
+        </p:txBody>
+      </p:sp>
+      <p:sp>
+        <p:nvSpPr>
+          <p:cNvPr id="18" name="TextBox 17"/>
           <p:cNvSpPr txBox="1"/>
           <p:nvPr/>
         </p:nvSpPr>
         <p:spPr>
           <a:xfrm>
-            <a:off x="6291072" y="2194560"/>
-            <a:ext cx="2231136" cy="3657600"/>
+            <a:off x="9034272" y="2176272"/>
+            <a:ext cx="2231136" cy="3840480"/>
           </a:xfrm>
           <a:prstGeom prst="rect">
             <a:avLst/>
@@ -5293,29 +5979,44 @@
           <a:lstStyle/>
           <a:p>
             <a:pPr>
-              <a:defRPr sz="1400" b="1">
+              <a:defRPr sz="1450" b="1">
                 <a:solidFill>
                   <a:srgbClr val="002D72"/>
                 </a:solidFill>
               </a:defRPr>
             </a:pPr>
             <a:r>
-              <a:t>Stage 3: 30% Customs</a:t>
+              <a:t>Stage 4: 20% Final DvP</a:t>
             </a:r>
           </a:p>
           <a:p>
             <a:pPr>
               <a:spcBef>
-                <a:spcPts val="400"/>
+                <a:spcPts val="300"/>
               </a:spcBef>
-              <a:defRPr sz="1050" b="1">
-                <a:solidFill>
-                  <a:srgbClr val="056DAE"/>
-                </a:solidFill>
-              </a:defRPr>
-            </a:pPr>
-            <a:r>
-              <a:t>ICEGATE Customs Out-of-Charge</a:t>
+              <a:defRPr sz="1100" b="1">
+                <a:solidFill>
+                  <a:srgbClr val="059669"/>
+                </a:solidFill>
+              </a:defRPr>
+            </a:pPr>
+            <a:r>
+              <a:t>Site Delivery &amp; Title Transfer</a:t>
+            </a:r>
+          </a:p>
+          <a:p>
+            <a:pPr>
+              <a:spcBef>
+                <a:spcPts val="800"/>
+              </a:spcBef>
+              <a:defRPr sz="1050">
+                <a:solidFill>
+                  <a:srgbClr val="1E293B"/>
+                </a:solidFill>
+              </a:defRPr>
+            </a:pPr>
+            <a:r>
+              <a:t>IoT GPS geofence reached. Final tranche disbursed, and legal title of goods (e-BL NFT) transfers atomically to buyer.</a:t>
             </a:r>
           </a:p>
           <a:p>
@@ -5323,176 +6024,14 @@
               <a:spcBef>
                 <a:spcPts val="1000"/>
               </a:spcBef>
-              <a:defRPr sz="1100">
-                <a:solidFill>
-                  <a:srgbClr val="212529"/>
-                </a:solidFill>
-              </a:defRPr>
-            </a:pPr>
-            <a:r>
-              <a:t>Indian Customs duty verified at Nhava Sheva (JNPT). Funds disbursed &amp; purpose-bound e-RUPI vouchers issued for port duties.</a:t>
-            </a:r>
-          </a:p>
-        </p:txBody>
-      </p:sp>
-      <p:sp>
-        <p:nvSpPr>
-          <p:cNvPr id="15" name="Rounded Rectangle 14"/>
-          <p:cNvSpPr/>
-          <p:nvPr/>
-        </p:nvSpPr>
-        <p:spPr>
-          <a:xfrm>
-            <a:off x="8823960" y="1371600"/>
-            <a:ext cx="2560320" cy="4754880"/>
-          </a:xfrm>
-          <a:prstGeom prst="roundRect">
-            <a:avLst/>
-          </a:prstGeom>
-          <a:solidFill>
-            <a:srgbClr val="FFFFFF"/>
-          </a:solidFill>
-          <a:ln w="15240">
-            <a:solidFill>
-              <a:srgbClr val="E2E8F0"/>
-            </a:solidFill>
-          </a:ln>
-        </p:spPr>
-        <p:style>
-          <a:lnRef idx="1">
-            <a:schemeClr val="accent1"/>
-          </a:lnRef>
-          <a:fillRef idx="3">
-            <a:schemeClr val="accent1"/>
-          </a:fillRef>
-          <a:effectRef idx="2">
-            <a:schemeClr val="accent1"/>
-          </a:effectRef>
-          <a:fontRef idx="minor">
-            <a:schemeClr val="lt1"/>
-          </a:fontRef>
-        </p:style>
-        <p:txBody>
-          <a:bodyPr rtlCol="0" anchor="ctr"/>
-          <a:lstStyle/>
-          <a:p>
-            <a:pPr algn="ctr"/>
-          </a:p>
-        </p:txBody>
-      </p:sp>
-      <p:sp>
-        <p:nvSpPr>
-          <p:cNvPr id="16" name="Oval 15"/>
-          <p:cNvSpPr/>
-          <p:nvPr/>
-        </p:nvSpPr>
-        <p:spPr>
-          <a:xfrm>
-            <a:off x="9006840" y="1600200"/>
-            <a:ext cx="502920" cy="502920"/>
-          </a:xfrm>
-          <a:prstGeom prst="ellipse">
-            <a:avLst/>
-          </a:prstGeom>
-          <a:solidFill>
-            <a:srgbClr val="002D72"/>
-          </a:solidFill>
-          <a:ln>
-            <a:noFill/>
-          </a:ln>
-        </p:spPr>
-        <p:style>
-          <a:lnRef idx="1">
-            <a:schemeClr val="accent1"/>
-          </a:lnRef>
-          <a:fillRef idx="3">
-            <a:schemeClr val="accent1"/>
-          </a:fillRef>
-          <a:effectRef idx="2">
-            <a:schemeClr val="accent1"/>
-          </a:effectRef>
-          <a:fontRef idx="minor">
-            <a:schemeClr val="lt1"/>
-          </a:fontRef>
-        </p:style>
-        <p:txBody>
-          <a:bodyPr rtlCol="0" anchor="ctr"/>
-          <a:lstStyle/>
-          <a:p>
-            <a:pPr algn="ctr">
-              <a:defRPr sz="1400" b="1">
-                <a:solidFill>
-                  <a:srgbClr val="FFFFFF"/>
-                </a:solidFill>
-              </a:defRPr>
-            </a:pPr>
-            <a:r>
-              <a:t>4</a:t>
-            </a:r>
-          </a:p>
-        </p:txBody>
-      </p:sp>
-      <p:sp>
-        <p:nvSpPr>
-          <p:cNvPr id="17" name="TextBox 16"/>
-          <p:cNvSpPr txBox="1"/>
-          <p:nvPr/>
-        </p:nvSpPr>
-        <p:spPr>
-          <a:xfrm>
-            <a:off x="8988552" y="2194560"/>
-            <a:ext cx="2231136" cy="3657600"/>
-          </a:xfrm>
-          <a:prstGeom prst="rect">
-            <a:avLst/>
-          </a:prstGeom>
-          <a:noFill/>
-        </p:spPr>
-        <p:txBody>
-          <a:bodyPr wrap="square">
-            <a:spAutoFit/>
-          </a:bodyPr>
-          <a:lstStyle/>
-          <a:p>
-            <a:pPr>
-              <a:defRPr sz="1400" b="1">
-                <a:solidFill>
-                  <a:srgbClr val="002D72"/>
-                </a:solidFill>
-              </a:defRPr>
-            </a:pPr>
-            <a:r>
-              <a:t>Stage 4: 20% Final DvP</a:t>
-            </a:r>
-          </a:p>
-          <a:p>
-            <a:pPr>
-              <a:spcBef>
-                <a:spcPts val="400"/>
-              </a:spcBef>
-              <a:defRPr sz="1050" b="1">
+              <a:defRPr sz="950" b="1">
                 <a:solidFill>
                   <a:srgbClr val="056DAE"/>
                 </a:solidFill>
               </a:defRPr>
             </a:pPr>
             <a:r>
-              <a:t>Site Delivery &amp; Title Transfer</a:t>
-            </a:r>
-          </a:p>
-          <a:p>
-            <a:pPr>
-              <a:spcBef>
-                <a:spcPts val="1000"/>
-              </a:spcBef>
-              <a:defRPr sz="1100">
-                <a:solidFill>
-                  <a:srgbClr val="212529"/>
-                </a:solidFill>
-              </a:defRPr>
-            </a:pPr>
-            <a:r>
-              <a:t>IoT GPS destination reached. Final tranche disbursed, and legal title of goods (e-BL NFT) transfers atomically to buyer.</a:t>
+              <a:t>⚡ Trigger: IoT GPS + Temp Telemetry</a:t>
             </a:r>
           </a:p>
         </p:txBody>
@@ -5560,14 +6099,59 @@
       </p:sp>
       <p:sp>
         <p:nvSpPr>
-          <p:cNvPr id="3" name="TextBox 2"/>
+          <p:cNvPr id="3" name="Rectangle 2"/>
+          <p:cNvSpPr/>
+          <p:nvPr/>
+        </p:nvSpPr>
+        <p:spPr>
+          <a:xfrm>
+            <a:off x="0" y="73152"/>
+            <a:ext cx="12191695" cy="1051560"/>
+          </a:xfrm>
+          <a:prstGeom prst="rect">
+            <a:avLst/>
+          </a:prstGeom>
+          <a:solidFill>
+            <a:srgbClr val="FFFFFF"/>
+          </a:solidFill>
+          <a:ln w="12700">
+            <a:solidFill>
+              <a:srgbClr val="E2E8F0"/>
+            </a:solidFill>
+          </a:ln>
+        </p:spPr>
+        <p:style>
+          <a:lnRef idx="1">
+            <a:schemeClr val="accent1"/>
+          </a:lnRef>
+          <a:fillRef idx="3">
+            <a:schemeClr val="accent1"/>
+          </a:fillRef>
+          <a:effectRef idx="2">
+            <a:schemeClr val="accent1"/>
+          </a:effectRef>
+          <a:fontRef idx="minor">
+            <a:schemeClr val="lt1"/>
+          </a:fontRef>
+        </p:style>
+        <p:txBody>
+          <a:bodyPr rtlCol="0" anchor="ctr"/>
+          <a:lstStyle/>
+          <a:p>
+            <a:pPr algn="ctr"/>
+          </a:p>
+        </p:txBody>
+      </p:sp>
+      <p:sp>
+        <p:nvSpPr>
+          <p:cNvPr id="4" name="TextBox 3"/>
           <p:cNvSpPr txBox="1"/>
           <p:nvPr/>
         </p:nvSpPr>
         <p:spPr>
           <a:xfrm>
-            <a:off x="731520" y="228600"/>
-            <a:ext cx="7772400" cy="320040"/>
+            <a:off x="731520" y="164592"/>
+            <a:ext cx="7772400" cy="256032"/>
           </a:xfrm>
           <a:prstGeom prst="rect">
             <a:avLst/>
@@ -5588,20 +6172,20 @@
               </a:defRPr>
             </a:pPr>
             <a:r>
-              <a:t>CITIFLOW ESCROW | INSTITUTIONAL TRADE &amp; DVP</a:t>
-            </a:r>
-          </a:p>
-        </p:txBody>
-      </p:sp>
-      <p:sp>
-        <p:nvSpPr>
-          <p:cNvPr id="4" name="TextBox 3"/>
+              <a:t>CITIFLOW ESCROW | INSTITUTIONAL TRADE SETTLEMENT</a:t>
+            </a:r>
+          </a:p>
+        </p:txBody>
+      </p:sp>
+      <p:sp>
+        <p:nvSpPr>
+          <p:cNvPr id="5" name="TextBox 4"/>
           <p:cNvSpPr txBox="1"/>
           <p:nvPr/>
         </p:nvSpPr>
         <p:spPr>
           <a:xfrm>
-            <a:off x="731520" y="502920"/>
+            <a:off x="731520" y="438912"/>
             <a:ext cx="8686800" cy="594360"/>
           </a:xfrm>
           <a:prstGeom prst="rect">
@@ -5616,7 +6200,7 @@
           <a:lstStyle/>
           <a:p>
             <a:pPr>
-              <a:defRPr sz="2200" b="1">
+              <a:defRPr sz="2100" b="1">
                 <a:solidFill>
                   <a:srgbClr val="002D72"/>
                 </a:solidFill>
@@ -5630,7 +6214,7 @@
       </p:sp>
       <p:pic>
         <p:nvPicPr>
-          <p:cNvPr id="5" name="Picture 4" descr="citi_logo.png"/>
+          <p:cNvPr id="6" name="Picture 5" descr="citi_logo.png"/>
           <p:cNvPicPr>
             <a:picLocks noChangeAspect="1"/>
           </p:cNvPicPr>
@@ -5644,8 +6228,8 @@
         </p:blipFill>
         <p:spPr>
           <a:xfrm>
-            <a:off x="10424160" y="292608"/>
-            <a:ext cx="1051560" cy="1051560"/>
+            <a:off x="10607040" y="292608"/>
+            <a:ext cx="960120" cy="960120"/>
           </a:xfrm>
           <a:prstGeom prst="rect">
             <a:avLst/>
@@ -5654,14 +6238,14 @@
       </p:pic>
       <p:sp>
         <p:nvSpPr>
-          <p:cNvPr id="6" name="Rounded Rectangle 5"/>
+          <p:cNvPr id="7" name="Rounded Rectangle 6"/>
           <p:cNvSpPr/>
           <p:nvPr/>
         </p:nvSpPr>
         <p:spPr>
           <a:xfrm>
-            <a:off x="731520" y="1371600"/>
-            <a:ext cx="5257800" cy="4754880"/>
+            <a:off x="777240" y="1353312"/>
+            <a:ext cx="5257800" cy="4846320"/>
           </a:xfrm>
           <a:prstGeom prst="roundRect">
             <a:avLst/>
@@ -5699,14 +6283,14 @@
       </p:sp>
       <p:sp>
         <p:nvSpPr>
-          <p:cNvPr id="7" name="TextBox 6"/>
+          <p:cNvPr id="8" name="TextBox 7"/>
           <p:cNvSpPr txBox="1"/>
           <p:nvPr/>
         </p:nvSpPr>
         <p:spPr>
           <a:xfrm>
-            <a:off x="960120" y="1600200"/>
-            <a:ext cx="4800600" cy="4297680"/>
+            <a:off x="1005840" y="1554480"/>
+            <a:ext cx="4800600" cy="4389120"/>
           </a:xfrm>
           <a:prstGeom prst="rect">
             <a:avLst/>
@@ -5720,14 +6304,14 @@
           <a:lstStyle/>
           <a:p>
             <a:pPr>
-              <a:defRPr sz="1800" b="1">
+              <a:defRPr sz="1750" b="1">
                 <a:solidFill>
                   <a:srgbClr val="002D72"/>
                 </a:solidFill>
               </a:defRPr>
             </a:pPr>
             <a:r>
-              <a:t>🏦 Citibank Institutional Treasury</a:t>
+              <a:t>🏦 Citibank Institutional Treasury Gateway</a:t>
             </a:r>
           </a:p>
           <a:p>
@@ -5735,14 +6319,14 @@
               <a:spcBef>
                 <a:spcPts val="800"/>
               </a:spcBef>
-              <a:defRPr sz="1150">
-                <a:solidFill>
-                  <a:srgbClr val="212529"/>
-                </a:solidFill>
-              </a:defRPr>
-            </a:pPr>
-            <a:r>
-              <a:t>• ISO 20022 pacs.008.001.08: Instant cross-border customer credit transfer payload generation.</a:t>
+              <a:defRPr sz="1100">
+                <a:solidFill>
+                  <a:srgbClr val="1E293B"/>
+                </a:solidFill>
+              </a:defRPr>
+            </a:pPr>
+            <a:r>
+              <a:t>• ISO 20022 pacs.008.001.08: Instant automated customer credit transfer payload generation ready for SWIFT/Fedwire.</a:t>
             </a:r>
           </a:p>
           <a:p>
@@ -5750,14 +6334,14 @@
               <a:spcBef>
                 <a:spcPts val="800"/>
               </a:spcBef>
-              <a:defRPr sz="1150">
-                <a:solidFill>
-                  <a:srgbClr val="212529"/>
-                </a:solidFill>
-              </a:defRPr>
-            </a:pPr>
-            <a:r>
-              <a:t>• camt.053 Real-Time Reporting: Automated end-of-day bank statement reconciliation for corporate audit.</a:t>
+              <a:defRPr sz="1100">
+                <a:solidFill>
+                  <a:srgbClr val="1E293B"/>
+                </a:solidFill>
+              </a:defRPr>
+            </a:pPr>
+            <a:r>
+              <a:t>• camt.053 Real-Time Statement Reporting: End-of-day bank statement cash reconciliation for instant corporate audit.</a:t>
             </a:r>
           </a:p>
           <a:p>
@@ -5765,14 +6349,14 @@
               <a:spcBef>
                 <a:spcPts val="800"/>
               </a:spcBef>
-              <a:defRPr sz="1150">
-                <a:solidFill>
-                  <a:srgbClr val="212529"/>
-                </a:solidFill>
-              </a:defRPr>
-            </a:pPr>
-            <a:r>
-              <a:t>• Citi FX Desk Spot Hedging: Dynamic live USD/INR market rates with locked spot hedging.</a:t>
+              <a:defRPr sz="1100">
+                <a:solidFill>
+                  <a:srgbClr val="1E293B"/>
+                </a:solidFill>
+              </a:defRPr>
+            </a:pPr>
+            <a:r>
+              <a:t>• Citi FX Desk Spot Hedging: Dynamic live USD/INR market feeds with forward hedge locking and liquidity spreads.</a:t>
             </a:r>
           </a:p>
           <a:p>
@@ -5780,28 +6364,28 @@
               <a:spcBef>
                 <a:spcPts val="800"/>
               </a:spcBef>
-              <a:defRPr sz="1150">
-                <a:solidFill>
-                  <a:srgbClr val="212529"/>
-                </a:solidFill>
-              </a:defRPr>
-            </a:pPr>
-            <a:r>
-              <a:t>• Corporate Escrow Vault: FDIC &amp; regulatory compliant holding accounts with yield optimization.</a:t>
-            </a:r>
-          </a:p>
-        </p:txBody>
-      </p:sp>
-      <p:sp>
-        <p:nvSpPr>
-          <p:cNvPr id="8" name="Rounded Rectangle 7"/>
+              <a:defRPr sz="1100">
+                <a:solidFill>
+                  <a:srgbClr val="1E293B"/>
+                </a:solidFill>
+              </a:defRPr>
+            </a:pPr>
+            <a:r>
+              <a:t>• Institutional Corporate Escrow Vault: FDIC &amp; RBI harmonized holding accounts with programmatic smart yield optimization.</a:t>
+            </a:r>
+          </a:p>
+        </p:txBody>
+      </p:sp>
+      <p:sp>
+        <p:nvSpPr>
+          <p:cNvPr id="9" name="Rounded Rectangle 8"/>
           <p:cNvSpPr/>
           <p:nvPr/>
         </p:nvSpPr>
         <p:spPr>
           <a:xfrm>
-            <a:off x="6199632" y="1371600"/>
-            <a:ext cx="5257800" cy="4754880"/>
+            <a:off x="6199632" y="1353312"/>
+            <a:ext cx="5257800" cy="4846320"/>
           </a:xfrm>
           <a:prstGeom prst="roundRect">
             <a:avLst/>
@@ -5839,14 +6423,14 @@
       </p:sp>
       <p:sp>
         <p:nvSpPr>
-          <p:cNvPr id="9" name="TextBox 8"/>
+          <p:cNvPr id="10" name="TextBox 9"/>
           <p:cNvSpPr txBox="1"/>
           <p:nvPr/>
         </p:nvSpPr>
         <p:spPr>
           <a:xfrm>
-            <a:off x="6428232" y="1600200"/>
-            <a:ext cx="4800600" cy="4297680"/>
+            <a:off x="6428232" y="1554480"/>
+            <a:ext cx="4800600" cy="4389120"/>
           </a:xfrm>
           <a:prstGeom prst="rect">
             <a:avLst/>
@@ -5860,7 +6444,7 @@
           <a:lstStyle/>
           <a:p>
             <a:pPr>
-              <a:defRPr sz="1800" b="1">
+              <a:defRPr sz="1750" b="1">
                 <a:solidFill>
                   <a:srgbClr val="D97706"/>
                 </a:solidFill>
@@ -5875,14 +6459,14 @@
               <a:spcBef>
                 <a:spcPts val="800"/>
               </a:spcBef>
-              <a:defRPr sz="1150">
-                <a:solidFill>
-                  <a:srgbClr val="212529"/>
-                </a:solidFill>
-              </a:defRPr>
-            </a:pPr>
-            <a:r>
-              <a:t>• 1-Click UPI 2.0 Intent: Instant execution via Google Pay, PhonePe, and BHIM UPI.</a:t>
+              <a:defRPr sz="1100">
+                <a:solidFill>
+                  <a:srgbClr val="1E293B"/>
+                </a:solidFill>
+              </a:defRPr>
+            </a:pPr>
+            <a:r>
+              <a:t>• 1-Click UPI 2.0 Real-Time Execution: Instant payment intent via Google Pay, PhonePe, and BHIM UPI 2.0.</a:t>
             </a:r>
           </a:p>
           <a:p>
@@ -5890,14 +6474,14 @@
               <a:spcBef>
                 <a:spcPts val="800"/>
               </a:spcBef>
-              <a:defRPr sz="1150">
-                <a:solidFill>
-                  <a:srgbClr val="212529"/>
-                </a:solidFill>
-              </a:defRPr>
-            </a:pPr>
-            <a:r>
-              <a:t>• UPI AutoPay Mandates: Event-triggered standing instructions for autonomous milestone funding.</a:t>
+              <a:defRPr sz="1100">
+                <a:solidFill>
+                  <a:srgbClr val="1E293B"/>
+                </a:solidFill>
+              </a:defRPr>
+            </a:pPr>
+            <a:r>
+              <a:t>• UPI AutoPay Standing Mandates: Event-triggered smart instructions for autonomous milestone tranche funding.</a:t>
             </a:r>
           </a:p>
           <a:p>
@@ -5905,14 +6489,14 @@
               <a:spcBef>
                 <a:spcPts val="800"/>
               </a:spcBef>
-              <a:defRPr sz="1150">
-                <a:solidFill>
-                  <a:srgbClr val="212529"/>
-                </a:solidFill>
-              </a:defRPr>
-            </a:pPr>
-            <a:r>
-              <a:t>• Purpose-Bound e-RUPI: Dedicated digital vouchers for customs duty and container demurrage.</a:t>
+              <a:defRPr sz="1100">
+                <a:solidFill>
+                  <a:srgbClr val="1E293B"/>
+                </a:solidFill>
+              </a:defRPr>
+            </a:pPr>
+            <a:r>
+              <a:t>• Purpose-Bound e-RUPI Vouchers: Dedicated digital vouchers for customs duty and container demurrage clearance.</a:t>
             </a:r>
           </a:p>
           <a:p>
@@ -5920,14 +6504,14 @@
               <a:spcBef>
                 <a:spcPts val="800"/>
               </a:spcBef>
-              <a:defRPr sz="1150">
-                <a:solidFill>
-                  <a:srgbClr val="212529"/>
-                </a:solidFill>
-              </a:defRPr>
-            </a:pPr>
-            <a:r>
-              <a:t>• Zero-Friction SME Access: Enables Indian MSMEs to participate in global trade without LC friction.</a:t>
+              <a:defRPr sz="1100">
+                <a:solidFill>
+                  <a:srgbClr val="1E293B"/>
+                </a:solidFill>
+              </a:defRPr>
+            </a:pPr>
+            <a:r>
+              <a:t>• Zero-Friction MSME Cross-Border Access: Enables Indian SMEs to trade globally with institutional escrow security.</a:t>
             </a:r>
           </a:p>
         </p:txBody>
@@ -5995,14 +6579,59 @@
       </p:sp>
       <p:sp>
         <p:nvSpPr>
-          <p:cNvPr id="3" name="TextBox 2"/>
+          <p:cNvPr id="3" name="Rectangle 2"/>
+          <p:cNvSpPr/>
+          <p:nvPr/>
+        </p:nvSpPr>
+        <p:spPr>
+          <a:xfrm>
+            <a:off x="0" y="73152"/>
+            <a:ext cx="12191695" cy="1051560"/>
+          </a:xfrm>
+          <a:prstGeom prst="rect">
+            <a:avLst/>
+          </a:prstGeom>
+          <a:solidFill>
+            <a:srgbClr val="FFFFFF"/>
+          </a:solidFill>
+          <a:ln w="12700">
+            <a:solidFill>
+              <a:srgbClr val="E2E8F0"/>
+            </a:solidFill>
+          </a:ln>
+        </p:spPr>
+        <p:style>
+          <a:lnRef idx="1">
+            <a:schemeClr val="accent1"/>
+          </a:lnRef>
+          <a:fillRef idx="3">
+            <a:schemeClr val="accent1"/>
+          </a:fillRef>
+          <a:effectRef idx="2">
+            <a:schemeClr val="accent1"/>
+          </a:effectRef>
+          <a:fontRef idx="minor">
+            <a:schemeClr val="lt1"/>
+          </a:fontRef>
+        </p:style>
+        <p:txBody>
+          <a:bodyPr rtlCol="0" anchor="ctr"/>
+          <a:lstStyle/>
+          <a:p>
+            <a:pPr algn="ctr"/>
+          </a:p>
+        </p:txBody>
+      </p:sp>
+      <p:sp>
+        <p:nvSpPr>
+          <p:cNvPr id="4" name="TextBox 3"/>
           <p:cNvSpPr txBox="1"/>
           <p:nvPr/>
         </p:nvSpPr>
         <p:spPr>
           <a:xfrm>
-            <a:off x="731520" y="228600"/>
-            <a:ext cx="7772400" cy="320040"/>
+            <a:off x="731520" y="164592"/>
+            <a:ext cx="7772400" cy="256032"/>
           </a:xfrm>
           <a:prstGeom prst="rect">
             <a:avLst/>
@@ -6023,20 +6652,20 @@
               </a:defRPr>
             </a:pPr>
             <a:r>
-              <a:t>CITIFLOW ESCROW | INSTITUTIONAL TRADE &amp; DVP</a:t>
-            </a:r>
-          </a:p>
-        </p:txBody>
-      </p:sp>
-      <p:sp>
-        <p:nvSpPr>
-          <p:cNvPr id="4" name="TextBox 3"/>
+              <a:t>CITIFLOW ESCROW | INSTITUTIONAL TRADE SETTLEMENT</a:t>
+            </a:r>
+          </a:p>
+        </p:txBody>
+      </p:sp>
+      <p:sp>
+        <p:nvSpPr>
+          <p:cNvPr id="5" name="TextBox 4"/>
           <p:cNvSpPr txBox="1"/>
           <p:nvPr/>
         </p:nvSpPr>
         <p:spPr>
           <a:xfrm>
-            <a:off x="731520" y="502920"/>
+            <a:off x="731520" y="438912"/>
             <a:ext cx="8686800" cy="594360"/>
           </a:xfrm>
           <a:prstGeom prst="rect">
@@ -6051,7 +6680,7 @@
           <a:lstStyle/>
           <a:p>
             <a:pPr>
-              <a:defRPr sz="2200" b="1">
+              <a:defRPr sz="2100" b="1">
                 <a:solidFill>
                   <a:srgbClr val="002D72"/>
                 </a:solidFill>
@@ -6065,7 +6694,7 @@
       </p:sp>
       <p:pic>
         <p:nvPicPr>
-          <p:cNvPr id="5" name="Picture 4" descr="citi_logo.png"/>
+          <p:cNvPr id="6" name="Picture 5" descr="citi_logo.png"/>
           <p:cNvPicPr>
             <a:picLocks noChangeAspect="1"/>
           </p:cNvPicPr>
@@ -6079,8 +6708,8 @@
         </p:blipFill>
         <p:spPr>
           <a:xfrm>
-            <a:off x="10424160" y="292608"/>
-            <a:ext cx="1051560" cy="1051560"/>
+            <a:off x="10607040" y="292608"/>
+            <a:ext cx="960120" cy="960120"/>
           </a:xfrm>
           <a:prstGeom prst="rect">
             <a:avLst/>
@@ -6089,15 +6718,15 @@
       </p:pic>
       <p:graphicFrame>
         <p:nvGraphicFramePr>
-          <p:cNvPr id="6" name="Table 5"/>
+          <p:cNvPr id="7" name="Table 6"/>
           <p:cNvGraphicFramePr>
             <a:graphicFrameLocks noGrp="1"/>
           </p:cNvGraphicFramePr>
           <p:nvPr/>
         </p:nvGraphicFramePr>
         <p:xfrm>
-          <a:off x="731520" y="1463040"/>
-          <a:ext cx="10728655" cy="4389120"/>
+          <a:off x="777240" y="1371600"/>
+          <a:ext cx="10680192" cy="4663440"/>
         </p:xfrm>
         <a:graphic>
           <a:graphicData uri="http://schemas.openxmlformats.org/drawingml/2006/table">
@@ -6108,24 +6737,24 @@
               <a:tblGrid>
                 <a:gridCol w="2377440"/>
                 <a:gridCol w="3291840"/>
-                <a:gridCol w="3474720"/>
-                <a:gridCol w="1584655"/>
+                <a:gridCol w="3456432"/>
+                <a:gridCol w="1554480"/>
               </a:tblGrid>
-              <a:tr h="731520">
+              <a:tr h="777240">
                 <a:tc>
                   <a:txBody>
                     <a:bodyPr/>
                     <a:lstStyle/>
                     <a:p>
                       <a:pPr algn="l">
-                        <a:defRPr b="1" sz="1150">
+                        <a:defRPr b="1" sz="1200">
                           <a:solidFill>
                             <a:srgbClr val="FFFFFF"/>
                           </a:solidFill>
                         </a:defRPr>
                       </a:pPr>
                       <a:r>
-                        <a:t>Metric / Dimension</a:t>
+                        <a:t>Dimension</a:t>
                       </a:r>
                     </a:p>
                   </a:txBody>
@@ -6141,7 +6770,7 @@
                     <a:lstStyle/>
                     <a:p>
                       <a:pPr algn="l">
-                        <a:defRPr b="1" sz="1150">
+                        <a:defRPr b="1" sz="1200">
                           <a:solidFill>
                             <a:srgbClr val="FFFFFF"/>
                           </a:solidFill>
@@ -6164,7 +6793,7 @@
                     <a:lstStyle/>
                     <a:p>
                       <a:pPr algn="l">
-                        <a:defRPr b="1" sz="1150">
+                        <a:defRPr b="1" sz="1200">
                           <a:solidFill>
                             <a:srgbClr val="FFFFFF"/>
                           </a:solidFill>
@@ -6187,7 +6816,7 @@
                     <a:lstStyle/>
                     <a:p>
                       <a:pPr algn="ctr">
-                        <a:defRPr b="1" sz="1150">
+                        <a:defRPr b="1" sz="1200">
                           <a:solidFill>
                             <a:srgbClr val="FFFFFF"/>
                           </a:solidFill>
@@ -6205,16 +6834,16 @@
                   </a:tcPr>
                 </a:tc>
               </a:tr>
-              <a:tr h="731520">
+              <a:tr h="777240">
                 <a:tc>
                   <a:txBody>
                     <a:bodyPr/>
                     <a:lstStyle/>
                     <a:p>
                       <a:pPr algn="l">
-                        <a:defRPr sz="1050">
+                        <a:defRPr sz="1100">
                           <a:solidFill>
-                            <a:srgbClr val="212529"/>
+                            <a:srgbClr val="1E293B"/>
                           </a:solidFill>
                         </a:defRPr>
                       </a:pPr>
@@ -6235,9 +6864,9 @@
                     <a:lstStyle/>
                     <a:p>
                       <a:pPr algn="l">
-                        <a:defRPr sz="1050">
+                        <a:defRPr sz="1100">
                           <a:solidFill>
-                            <a:srgbClr val="212529"/>
+                            <a:srgbClr val="1E293B"/>
                           </a:solidFill>
                         </a:defRPr>
                       </a:pPr>
@@ -6258,7 +6887,7 @@
                     <a:lstStyle/>
                     <a:p>
                       <a:pPr algn="l">
-                        <a:defRPr sz="1050" b="1">
+                        <a:defRPr sz="1100" b="1">
                           <a:solidFill>
                             <a:srgbClr val="056DAE"/>
                           </a:solidFill>
@@ -6281,9 +6910,9 @@
                     <a:lstStyle/>
                     <a:p>
                       <a:pPr algn="ctr">
-                        <a:defRPr sz="1050" b="1">
+                        <a:defRPr sz="1100" b="1">
                           <a:solidFill>
-                            <a:srgbClr val="018136"/>
+                            <a:srgbClr val="059669"/>
                           </a:solidFill>
                         </a:defRPr>
                       </a:pPr>
@@ -6299,16 +6928,16 @@
                   </a:tcPr>
                 </a:tc>
               </a:tr>
-              <a:tr h="731520">
+              <a:tr h="777240">
                 <a:tc>
                   <a:txBody>
                     <a:bodyPr/>
                     <a:lstStyle/>
                     <a:p>
                       <a:pPr algn="l">
-                        <a:defRPr sz="1050">
+                        <a:defRPr sz="1100">
                           <a:solidFill>
-                            <a:srgbClr val="212529"/>
+                            <a:srgbClr val="1E293B"/>
                           </a:solidFill>
                         </a:defRPr>
                       </a:pPr>
@@ -6329,14 +6958,14 @@
                     <a:lstStyle/>
                     <a:p>
                       <a:pPr algn="l">
-                        <a:defRPr sz="1050">
+                        <a:defRPr sz="1100">
                           <a:solidFill>
-                            <a:srgbClr val="212529"/>
+                            <a:srgbClr val="1E293B"/>
                           </a:solidFill>
                         </a:defRPr>
                       </a:pPr>
                       <a:r>
-                        <a:t>2.5% to 4.0% of deal value</a:t>
+                        <a:t>2.5% to 4.0% of trade value</a:t>
                       </a:r>
                     </a:p>
                   </a:txBody>
@@ -6352,7 +6981,7 @@
                     <a:lstStyle/>
                     <a:p>
                       <a:pPr algn="l">
-                        <a:defRPr sz="1050" b="1">
+                        <a:defRPr sz="1100" b="1">
                           <a:solidFill>
                             <a:srgbClr val="056DAE"/>
                           </a:solidFill>
@@ -6375,9 +7004,9 @@
                     <a:lstStyle/>
                     <a:p>
                       <a:pPr algn="ctr">
-                        <a:defRPr sz="1050" b="1">
+                        <a:defRPr sz="1100" b="1">
                           <a:solidFill>
-                            <a:srgbClr val="018136"/>
+                            <a:srgbClr val="059669"/>
                           </a:solidFill>
                         </a:defRPr>
                       </a:pPr>
@@ -6393,16 +7022,16 @@
                   </a:tcPr>
                 </a:tc>
               </a:tr>
-              <a:tr h="731520">
+              <a:tr h="777240">
                 <a:tc>
                   <a:txBody>
                     <a:bodyPr/>
                     <a:lstStyle/>
                     <a:p>
                       <a:pPr algn="l">
-                        <a:defRPr sz="1050">
+                        <a:defRPr sz="1100">
                           <a:solidFill>
-                            <a:srgbClr val="212529"/>
+                            <a:srgbClr val="1E293B"/>
                           </a:solidFill>
                         </a:defRPr>
                       </a:pPr>
@@ -6423,14 +7052,14 @@
                     <a:lstStyle/>
                     <a:p>
                       <a:pPr algn="l">
-                        <a:defRPr sz="1050">
+                        <a:defRPr sz="1100">
                           <a:solidFill>
-                            <a:srgbClr val="212529"/>
+                            <a:srgbClr val="1E293B"/>
                           </a:solidFill>
                         </a:defRPr>
                       </a:pPr>
                       <a:r>
-                        <a:t>Non-Atomic (Separate Courier)</a:t>
+                        <a:t>Non-Atomic (Separate paper transfer)</a:t>
                       </a:r>
                     </a:p>
                   </a:txBody>
@@ -6446,14 +7075,14 @@
                     <a:lstStyle/>
                     <a:p>
                       <a:pPr algn="l">
-                        <a:defRPr sz="1050" b="1">
+                        <a:defRPr sz="1100" b="1">
                           <a:solidFill>
                             <a:srgbClr val="056DAE"/>
                           </a:solidFill>
                         </a:defRPr>
                       </a:pPr>
                       <a:r>
-                        <a:t>100% Atomic on Drunix (ERC-721 e-BL)</a:t>
+                        <a:t>100% Atomic on-chain (ERC-721 e-BL)</a:t>
                       </a:r>
                     </a:p>
                   </a:txBody>
@@ -6469,9 +7098,9 @@
                     <a:lstStyle/>
                     <a:p>
                       <a:pPr algn="ctr">
-                        <a:defRPr sz="1050" b="1">
+                        <a:defRPr sz="1100" b="1">
                           <a:solidFill>
-                            <a:srgbClr val="018136"/>
+                            <a:srgbClr val="059669"/>
                           </a:solidFill>
                         </a:defRPr>
                       </a:pPr>
@@ -6487,16 +7116,16 @@
                   </a:tcPr>
                 </a:tc>
               </a:tr>
-              <a:tr h="731520">
+              <a:tr h="777240">
                 <a:tc>
                   <a:txBody>
                     <a:bodyPr/>
                     <a:lstStyle/>
                     <a:p>
                       <a:pPr algn="l">
-                        <a:defRPr sz="1050">
+                        <a:defRPr sz="1100">
                           <a:solidFill>
-                            <a:srgbClr val="212529"/>
+                            <a:srgbClr val="1E293B"/>
                           </a:solidFill>
                         </a:defRPr>
                       </a:pPr>
@@ -6517,14 +7146,14 @@
                     <a:lstStyle/>
                     <a:p>
                       <a:pPr algn="l">
-                        <a:defRPr sz="1050">
+                        <a:defRPr sz="1100">
                           <a:solidFill>
-                            <a:srgbClr val="212529"/>
+                            <a:srgbClr val="1E293B"/>
                           </a:solidFill>
                         </a:defRPr>
                       </a:pPr>
                       <a:r>
-                        <a:t>Manual Chq / Offline RTGS</a:t>
+                        <a:t>Manual cheques / Offline RTGS</a:t>
                       </a:r>
                     </a:p>
                   </a:txBody>
@@ -6540,7 +7169,7 @@
                     <a:lstStyle/>
                     <a:p>
                       <a:pPr algn="l">
-                        <a:defRPr sz="1050" b="1">
+                        <a:defRPr sz="1100" b="1">
                           <a:solidFill>
                             <a:srgbClr val="056DAE"/>
                           </a:solidFill>
@@ -6563,9 +7192,9 @@
                     <a:lstStyle/>
                     <a:p>
                       <a:pPr algn="ctr">
-                        <a:defRPr sz="1050" b="1">
+                        <a:defRPr sz="1100" b="1">
                           <a:solidFill>
-                            <a:srgbClr val="018136"/>
+                            <a:srgbClr val="059669"/>
                           </a:solidFill>
                         </a:defRPr>
                       </a:pPr>
@@ -6581,16 +7210,16 @@
                   </a:tcPr>
                 </a:tc>
               </a:tr>
-              <a:tr h="731520">
+              <a:tr h="777240">
                 <a:tc>
                   <a:txBody>
                     <a:bodyPr/>
                     <a:lstStyle/>
                     <a:p>
                       <a:pPr algn="l">
-                        <a:defRPr sz="1050">
+                        <a:defRPr sz="1100">
                           <a:solidFill>
-                            <a:srgbClr val="212529"/>
+                            <a:srgbClr val="1E293B"/>
                           </a:solidFill>
                         </a:defRPr>
                       </a:pPr>
@@ -6611,14 +7240,14 @@
                     <a:lstStyle/>
                     <a:p>
                       <a:pPr algn="l">
-                        <a:defRPr sz="1050">
+                        <a:defRPr sz="1100">
                           <a:solidFill>
-                            <a:srgbClr val="212529"/>
+                            <a:srgbClr val="1E293B"/>
                           </a:solidFill>
                         </a:defRPr>
                       </a:pPr>
                       <a:r>
-                        <a:t>Manual EDPMS/IDPMS reconciliation</a:t>
+                        <a:t>Manual EDPMS / IDPMS paperwork</a:t>
                       </a:r>
                     </a:p>
                   </a:txBody>
@@ -6634,14 +7263,14 @@
                     <a:lstStyle/>
                     <a:p>
                       <a:pPr algn="l">
-                        <a:defRPr sz="1050" b="1">
+                        <a:defRPr sz="1100" b="1">
                           <a:solidFill>
                             <a:srgbClr val="056DAE"/>
                           </a:solidFill>
                         </a:defRPr>
                       </a:pPr>
                       <a:r>
-                        <a:t>Automated ISO 20022 XML &amp; On-Chain Proof</a:t>
+                        <a:t>Automated ISO 20022 XML &amp; Audit Trail</a:t>
                       </a:r>
                     </a:p>
                   </a:txBody>
@@ -6657,9 +7286,9 @@
                     <a:lstStyle/>
                     <a:p>
                       <a:pPr algn="ctr">
-                        <a:defRPr sz="1050" b="1">
+                        <a:defRPr sz="1100" b="1">
                           <a:solidFill>
-                            <a:srgbClr val="018136"/>
+                            <a:srgbClr val="059669"/>
                           </a:solidFill>
                         </a:defRPr>
                       </a:pPr>
@@ -6742,14 +7371,59 @@
       </p:sp>
       <p:sp>
         <p:nvSpPr>
-          <p:cNvPr id="3" name="TextBox 2"/>
+          <p:cNvPr id="3" name="Rectangle 2"/>
+          <p:cNvSpPr/>
+          <p:nvPr/>
+        </p:nvSpPr>
+        <p:spPr>
+          <a:xfrm>
+            <a:off x="0" y="73152"/>
+            <a:ext cx="12191695" cy="1051560"/>
+          </a:xfrm>
+          <a:prstGeom prst="rect">
+            <a:avLst/>
+          </a:prstGeom>
+          <a:solidFill>
+            <a:srgbClr val="FFFFFF"/>
+          </a:solidFill>
+          <a:ln w="12700">
+            <a:solidFill>
+              <a:srgbClr val="E2E8F0"/>
+            </a:solidFill>
+          </a:ln>
+        </p:spPr>
+        <p:style>
+          <a:lnRef idx="1">
+            <a:schemeClr val="accent1"/>
+          </a:lnRef>
+          <a:fillRef idx="3">
+            <a:schemeClr val="accent1"/>
+          </a:fillRef>
+          <a:effectRef idx="2">
+            <a:schemeClr val="accent1"/>
+          </a:effectRef>
+          <a:fontRef idx="minor">
+            <a:schemeClr val="lt1"/>
+          </a:fontRef>
+        </p:style>
+        <p:txBody>
+          <a:bodyPr rtlCol="0" anchor="ctr"/>
+          <a:lstStyle/>
+          <a:p>
+            <a:pPr algn="ctr"/>
+          </a:p>
+        </p:txBody>
+      </p:sp>
+      <p:sp>
+        <p:nvSpPr>
+          <p:cNvPr id="4" name="TextBox 3"/>
           <p:cNvSpPr txBox="1"/>
           <p:nvPr/>
         </p:nvSpPr>
         <p:spPr>
           <a:xfrm>
-            <a:off x="731520" y="228600"/>
-            <a:ext cx="7772400" cy="320040"/>
+            <a:off x="731520" y="164592"/>
+            <a:ext cx="7772400" cy="256032"/>
           </a:xfrm>
           <a:prstGeom prst="rect">
             <a:avLst/>
@@ -6770,20 +7444,20 @@
               </a:defRPr>
             </a:pPr>
             <a:r>
-              <a:t>CITIFLOW ESCROW | INSTITUTIONAL TRADE &amp; DVP</a:t>
-            </a:r>
-          </a:p>
-        </p:txBody>
-      </p:sp>
-      <p:sp>
-        <p:nvSpPr>
-          <p:cNvPr id="4" name="TextBox 3"/>
+              <a:t>CITIFLOW ESCROW | INSTITUTIONAL TRADE SETTLEMENT</a:t>
+            </a:r>
+          </a:p>
+        </p:txBody>
+      </p:sp>
+      <p:sp>
+        <p:nvSpPr>
+          <p:cNvPr id="5" name="TextBox 4"/>
           <p:cNvSpPr txBox="1"/>
           <p:nvPr/>
         </p:nvSpPr>
         <p:spPr>
           <a:xfrm>
-            <a:off x="731520" y="502920"/>
+            <a:off x="731520" y="438912"/>
             <a:ext cx="8686800" cy="594360"/>
           </a:xfrm>
           <a:prstGeom prst="rect">
@@ -6798,7 +7472,7 @@
           <a:lstStyle/>
           <a:p>
             <a:pPr>
-              <a:defRPr sz="2200" b="1">
+              <a:defRPr sz="2100" b="1">
                 <a:solidFill>
                   <a:srgbClr val="002D72"/>
                 </a:solidFill>
@@ -6812,7 +7486,7 @@
       </p:sp>
       <p:pic>
         <p:nvPicPr>
-          <p:cNvPr id="5" name="Picture 4" descr="citi_logo.png"/>
+          <p:cNvPr id="6" name="Picture 5" descr="citi_logo.png"/>
           <p:cNvPicPr>
             <a:picLocks noChangeAspect="1"/>
           </p:cNvPicPr>
@@ -6826,8 +7500,8 @@
         </p:blipFill>
         <p:spPr>
           <a:xfrm>
-            <a:off x="10424160" y="292608"/>
-            <a:ext cx="1051560" cy="1051560"/>
+            <a:off x="10607040" y="292608"/>
+            <a:ext cx="960120" cy="960120"/>
           </a:xfrm>
           <a:prstGeom prst="rect">
             <a:avLst/>
@@ -6836,14 +7510,14 @@
       </p:pic>
       <p:sp>
         <p:nvSpPr>
-          <p:cNvPr id="6" name="Rounded Rectangle 5"/>
+          <p:cNvPr id="7" name="Rounded Rectangle 6"/>
           <p:cNvSpPr/>
           <p:nvPr/>
         </p:nvSpPr>
         <p:spPr>
           <a:xfrm>
-            <a:off x="731520" y="1371600"/>
-            <a:ext cx="5257800" cy="2148840"/>
+            <a:off x="777240" y="1371600"/>
+            <a:ext cx="5257800" cy="2194560"/>
           </a:xfrm>
           <a:prstGeom prst="roundRect">
             <a:avLst/>
@@ -6881,14 +7555,14 @@
       </p:sp>
       <p:sp>
         <p:nvSpPr>
-          <p:cNvPr id="7" name="TextBox 6"/>
+          <p:cNvPr id="8" name="TextBox 7"/>
           <p:cNvSpPr txBox="1"/>
           <p:nvPr/>
         </p:nvSpPr>
         <p:spPr>
           <a:xfrm>
-            <a:off x="960120" y="1554480"/>
-            <a:ext cx="4800600" cy="1783080"/>
+            <a:off x="1005840" y="1536192"/>
+            <a:ext cx="4800600" cy="1874519"/>
           </a:xfrm>
           <a:prstGeom prst="rect">
             <a:avLst/>
@@ -6902,7 +7576,7 @@
           <a:lstStyle/>
           <a:p>
             <a:pPr>
-              <a:defRPr sz="1500" b="1">
+              <a:defRPr sz="1550" b="1">
                 <a:solidFill>
                   <a:srgbClr val="002D72"/>
                 </a:solidFill>
@@ -6919,7 +7593,7 @@
               </a:spcBef>
               <a:defRPr sz="1100" b="1">
                 <a:solidFill>
-                  <a:srgbClr val="018136"/>
+                  <a:srgbClr val="059669"/>
                 </a:solidFill>
               </a:defRPr>
             </a:pPr>
@@ -6934,26 +7608,26 @@
               </a:spcBef>
               <a:defRPr sz="1100">
                 <a:solidFill>
-                  <a:srgbClr val="212529"/>
-                </a:solidFill>
-              </a:defRPr>
-            </a:pPr>
-            <a:r>
-              <a:t>Charged to the trade participants upon successful escrow completion. Saves enterprises 85% compared to 2-4% traditional LC costs while generating high-margin protocol revenue.</a:t>
-            </a:r>
-          </a:p>
-        </p:txBody>
-      </p:sp>
-      <p:sp>
-        <p:nvSpPr>
-          <p:cNvPr id="8" name="Rounded Rectangle 7"/>
+                  <a:srgbClr val="1E293B"/>
+                </a:solidFill>
+              </a:defRPr>
+            </a:pPr>
+            <a:r>
+              <a:t>Charged to trade participants upon successful milestone execution. Saves enterprises 85% compared to 2-4% traditional LC costs while generating high-margin protocol revenue.</a:t>
+            </a:r>
+          </a:p>
+        </p:txBody>
+      </p:sp>
+      <p:sp>
+        <p:nvSpPr>
+          <p:cNvPr id="9" name="Rounded Rectangle 8"/>
           <p:cNvSpPr/>
           <p:nvPr/>
         </p:nvSpPr>
         <p:spPr>
           <a:xfrm>
-            <a:off x="6172200" y="1371600"/>
-            <a:ext cx="5257800" cy="2148840"/>
+            <a:off x="6217920" y="1371600"/>
+            <a:ext cx="5257800" cy="2194560"/>
           </a:xfrm>
           <a:prstGeom prst="roundRect">
             <a:avLst/>
@@ -6991,14 +7665,14 @@
       </p:sp>
       <p:sp>
         <p:nvSpPr>
-          <p:cNvPr id="9" name="TextBox 8"/>
+          <p:cNvPr id="10" name="TextBox 9"/>
           <p:cNvSpPr txBox="1"/>
           <p:nvPr/>
         </p:nvSpPr>
         <p:spPr>
           <a:xfrm>
-            <a:off x="6400800" y="1554480"/>
-            <a:ext cx="4800600" cy="1783080"/>
+            <a:off x="6446520" y="1536192"/>
+            <a:ext cx="4800600" cy="1874519"/>
           </a:xfrm>
           <a:prstGeom prst="rect">
             <a:avLst/>
@@ -7012,7 +7686,7 @@
           <a:lstStyle/>
           <a:p>
             <a:pPr>
-              <a:defRPr sz="1500" b="1">
+              <a:defRPr sz="1550" b="1">
                 <a:solidFill>
                   <a:srgbClr val="002D72"/>
                 </a:solidFill>
@@ -7029,7 +7703,7 @@
               </a:spcBef>
               <a:defRPr sz="1100" b="1">
                 <a:solidFill>
-                  <a:srgbClr val="018136"/>
+                  <a:srgbClr val="059669"/>
                 </a:solidFill>
               </a:defRPr>
             </a:pPr>
@@ -7044,26 +7718,26 @@
               </a:spcBef>
               <a:defRPr sz="1100">
                 <a:solidFill>
-                  <a:srgbClr val="212529"/>
-                </a:solidFill>
-              </a:defRPr>
-            </a:pPr>
-            <a:r>
-              <a:t>Citibank captures spot FX spread on cross-border corridor conversion (USD to INR) while optimizing institutional treasury float on locked escrow capital.</a:t>
-            </a:r>
-          </a:p>
-        </p:txBody>
-      </p:sp>
-      <p:sp>
-        <p:nvSpPr>
-          <p:cNvPr id="10" name="Rounded Rectangle 9"/>
+                  <a:srgbClr val="1E293B"/>
+                </a:solidFill>
+              </a:defRPr>
+            </a:pPr>
+            <a:r>
+              <a:t>Citibank captures spot FX spread on cross-border corridor conversions (USD to INR) while optimizing institutional treasury float yield on locked escrow deposits.</a:t>
+            </a:r>
+          </a:p>
+        </p:txBody>
+      </p:sp>
+      <p:sp>
+        <p:nvSpPr>
+          <p:cNvPr id="11" name="Rounded Rectangle 10"/>
           <p:cNvSpPr/>
           <p:nvPr/>
         </p:nvSpPr>
         <p:spPr>
           <a:xfrm>
-            <a:off x="731520" y="3749039"/>
-            <a:ext cx="5257800" cy="2148840"/>
+            <a:off x="777240" y="3767328"/>
+            <a:ext cx="5257800" cy="2194560"/>
           </a:xfrm>
           <a:prstGeom prst="roundRect">
             <a:avLst/>
@@ -7101,14 +7775,14 @@
       </p:sp>
       <p:sp>
         <p:nvSpPr>
-          <p:cNvPr id="11" name="TextBox 10"/>
+          <p:cNvPr id="12" name="TextBox 11"/>
           <p:cNvSpPr txBox="1"/>
           <p:nvPr/>
         </p:nvSpPr>
         <p:spPr>
           <a:xfrm>
-            <a:off x="960120" y="3931920"/>
-            <a:ext cx="4800600" cy="1783080"/>
+            <a:off x="1005840" y="3931920"/>
+            <a:ext cx="4800600" cy="1874519"/>
           </a:xfrm>
           <a:prstGeom prst="rect">
             <a:avLst/>
@@ -7122,7 +7796,7 @@
           <a:lstStyle/>
           <a:p>
             <a:pPr>
-              <a:defRPr sz="1500" b="1">
+              <a:defRPr sz="1550" b="1">
                 <a:solidFill>
                   <a:srgbClr val="002D72"/>
                 </a:solidFill>
@@ -7139,7 +7813,7 @@
               </a:spcBef>
               <a:defRPr sz="1100" b="1">
                 <a:solidFill>
-                  <a:srgbClr val="018136"/>
+                  <a:srgbClr val="059669"/>
                 </a:solidFill>
               </a:defRPr>
             </a:pPr>
@@ -7154,26 +7828,26 @@
               </a:spcBef>
               <a:defRPr sz="1100">
                 <a:solidFill>
-                  <a:srgbClr val="212529"/>
-                </a:solidFill>
-              </a:defRPr>
-            </a:pPr>
-            <a:r>
-              <a:t>Enterprise subscription tiers for freight forwarders, terminal operators (JNPT/Mundra), and inspection agencies (TÜV SÜD) to attest verified data to Drunix.</a:t>
-            </a:r>
-          </a:p>
-        </p:txBody>
-      </p:sp>
-      <p:sp>
-        <p:nvSpPr>
-          <p:cNvPr id="12" name="Rounded Rectangle 11"/>
+                  <a:srgbClr val="1E293B"/>
+                </a:solidFill>
+              </a:defRPr>
+            </a:pPr>
+            <a:r>
+              <a:t>Enterprise SaaS subscription tiers for freight forwarders, terminal operators (JNPT/Mundra), and inspection agencies (TÜV SÜD) to attest verified data to Drunix.</a:t>
+            </a:r>
+          </a:p>
+        </p:txBody>
+      </p:sp>
+      <p:sp>
+        <p:nvSpPr>
+          <p:cNvPr id="13" name="Rounded Rectangle 12"/>
           <p:cNvSpPr/>
           <p:nvPr/>
         </p:nvSpPr>
         <p:spPr>
           <a:xfrm>
-            <a:off x="6172200" y="3749039"/>
-            <a:ext cx="5257800" cy="2148840"/>
+            <a:off x="6217920" y="3767328"/>
+            <a:ext cx="5257800" cy="2194560"/>
           </a:xfrm>
           <a:prstGeom prst="roundRect">
             <a:avLst/>
@@ -7211,14 +7885,14 @@
       </p:sp>
       <p:sp>
         <p:nvSpPr>
-          <p:cNvPr id="13" name="TextBox 12"/>
+          <p:cNvPr id="14" name="TextBox 13"/>
           <p:cNvSpPr txBox="1"/>
           <p:nvPr/>
         </p:nvSpPr>
         <p:spPr>
           <a:xfrm>
-            <a:off x="6400800" y="3931920"/>
-            <a:ext cx="4800600" cy="1783080"/>
+            <a:off x="6446520" y="3931920"/>
+            <a:ext cx="4800600" cy="1874519"/>
           </a:xfrm>
           <a:prstGeom prst="rect">
             <a:avLst/>
@@ -7232,7 +7906,7 @@
           <a:lstStyle/>
           <a:p>
             <a:pPr>
-              <a:defRPr sz="1500" b="1">
+              <a:defRPr sz="1550" b="1">
                 <a:solidFill>
                   <a:srgbClr val="002D72"/>
                 </a:solidFill>
@@ -7249,7 +7923,7 @@
               </a:spcBef>
               <a:defRPr sz="1100" b="1">
                 <a:solidFill>
-                  <a:srgbClr val="018136"/>
+                  <a:srgbClr val="059669"/>
                 </a:solidFill>
               </a:defRPr>
             </a:pPr>
@@ -7264,7 +7938,7 @@
               </a:spcBef>
               <a:defRPr sz="1100">
                 <a:solidFill>
-                  <a:srgbClr val="212529"/>
+                  <a:srgbClr val="1E293B"/>
                 </a:solidFill>
               </a:defRPr>
             </a:pPr>
@@ -7337,14 +8011,59 @@
       </p:sp>
       <p:sp>
         <p:nvSpPr>
-          <p:cNvPr id="3" name="TextBox 2"/>
+          <p:cNvPr id="3" name="Rectangle 2"/>
+          <p:cNvSpPr/>
+          <p:nvPr/>
+        </p:nvSpPr>
+        <p:spPr>
+          <a:xfrm>
+            <a:off x="0" y="73152"/>
+            <a:ext cx="12191695" cy="1051560"/>
+          </a:xfrm>
+          <a:prstGeom prst="rect">
+            <a:avLst/>
+          </a:prstGeom>
+          <a:solidFill>
+            <a:srgbClr val="FFFFFF"/>
+          </a:solidFill>
+          <a:ln w="12700">
+            <a:solidFill>
+              <a:srgbClr val="E2E8F0"/>
+            </a:solidFill>
+          </a:ln>
+        </p:spPr>
+        <p:style>
+          <a:lnRef idx="1">
+            <a:schemeClr val="accent1"/>
+          </a:lnRef>
+          <a:fillRef idx="3">
+            <a:schemeClr val="accent1"/>
+          </a:fillRef>
+          <a:effectRef idx="2">
+            <a:schemeClr val="accent1"/>
+          </a:effectRef>
+          <a:fontRef idx="minor">
+            <a:schemeClr val="lt1"/>
+          </a:fontRef>
+        </p:style>
+        <p:txBody>
+          <a:bodyPr rtlCol="0" anchor="ctr"/>
+          <a:lstStyle/>
+          <a:p>
+            <a:pPr algn="ctr"/>
+          </a:p>
+        </p:txBody>
+      </p:sp>
+      <p:sp>
+        <p:nvSpPr>
+          <p:cNvPr id="4" name="TextBox 3"/>
           <p:cNvSpPr txBox="1"/>
           <p:nvPr/>
         </p:nvSpPr>
         <p:spPr>
           <a:xfrm>
-            <a:off x="731520" y="228600"/>
-            <a:ext cx="7772400" cy="320040"/>
+            <a:off x="731520" y="164592"/>
+            <a:ext cx="7772400" cy="256032"/>
           </a:xfrm>
           <a:prstGeom prst="rect">
             <a:avLst/>
@@ -7365,20 +8084,20 @@
               </a:defRPr>
             </a:pPr>
             <a:r>
-              <a:t>CITIFLOW ESCROW | INSTITUTIONAL TRADE &amp; DVP</a:t>
-            </a:r>
-          </a:p>
-        </p:txBody>
-      </p:sp>
-      <p:sp>
-        <p:nvSpPr>
-          <p:cNvPr id="4" name="TextBox 3"/>
+              <a:t>CITIFLOW ESCROW | INSTITUTIONAL TRADE SETTLEMENT</a:t>
+            </a:r>
+          </a:p>
+        </p:txBody>
+      </p:sp>
+      <p:sp>
+        <p:nvSpPr>
+          <p:cNvPr id="5" name="TextBox 4"/>
           <p:cNvSpPr txBox="1"/>
           <p:nvPr/>
         </p:nvSpPr>
         <p:spPr>
           <a:xfrm>
-            <a:off x="731520" y="502920"/>
+            <a:off x="731520" y="438912"/>
             <a:ext cx="8686800" cy="594360"/>
           </a:xfrm>
           <a:prstGeom prst="rect">
@@ -7393,7 +8112,7 @@
           <a:lstStyle/>
           <a:p>
             <a:pPr>
-              <a:defRPr sz="2200" b="1">
+              <a:defRPr sz="2100" b="1">
                 <a:solidFill>
                   <a:srgbClr val="002D72"/>
                 </a:solidFill>
@@ -7407,7 +8126,7 @@
       </p:sp>
       <p:pic>
         <p:nvPicPr>
-          <p:cNvPr id="5" name="Picture 4" descr="citi_logo.png"/>
+          <p:cNvPr id="6" name="Picture 5" descr="citi_logo.png"/>
           <p:cNvPicPr>
             <a:picLocks noChangeAspect="1"/>
           </p:cNvPicPr>
@@ -7421,8 +8140,8 @@
         </p:blipFill>
         <p:spPr>
           <a:xfrm>
-            <a:off x="10424160" y="292608"/>
-            <a:ext cx="1051560" cy="1051560"/>
+            <a:off x="10607040" y="292608"/>
+            <a:ext cx="960120" cy="960120"/>
           </a:xfrm>
           <a:prstGeom prst="rect">
             <a:avLst/>
@@ -7431,13 +8150,13 @@
       </p:pic>
       <p:sp>
         <p:nvSpPr>
-          <p:cNvPr id="6" name="Rounded Rectangle 5"/>
+          <p:cNvPr id="7" name="Rounded Rectangle 6"/>
           <p:cNvSpPr/>
           <p:nvPr/>
         </p:nvSpPr>
         <p:spPr>
           <a:xfrm>
-            <a:off x="731520" y="1371600"/>
+            <a:off x="777240" y="1371600"/>
             <a:ext cx="3474720" cy="3474720"/>
           </a:xfrm>
           <a:prstGeom prst="roundRect">
@@ -7476,13 +8195,56 @@
       </p:sp>
       <p:sp>
         <p:nvSpPr>
-          <p:cNvPr id="7" name="TextBox 6"/>
+          <p:cNvPr id="8" name="Rectangle 7"/>
+          <p:cNvSpPr/>
+          <p:nvPr/>
+        </p:nvSpPr>
+        <p:spPr>
+          <a:xfrm>
+            <a:off x="777240" y="1371600"/>
+            <a:ext cx="3474720" cy="73152"/>
+          </a:xfrm>
+          <a:prstGeom prst="rect">
+            <a:avLst/>
+          </a:prstGeom>
+          <a:solidFill>
+            <a:srgbClr val="056DAE"/>
+          </a:solidFill>
+          <a:ln>
+            <a:noFill/>
+          </a:ln>
+        </p:spPr>
+        <p:style>
+          <a:lnRef idx="1">
+            <a:schemeClr val="accent1"/>
+          </a:lnRef>
+          <a:fillRef idx="3">
+            <a:schemeClr val="accent1"/>
+          </a:fillRef>
+          <a:effectRef idx="2">
+            <a:schemeClr val="accent1"/>
+          </a:effectRef>
+          <a:fontRef idx="minor">
+            <a:schemeClr val="lt1"/>
+          </a:fontRef>
+        </p:style>
+        <p:txBody>
+          <a:bodyPr rtlCol="0" anchor="ctr"/>
+          <a:lstStyle/>
+          <a:p>
+            <a:pPr algn="ctr"/>
+          </a:p>
+        </p:txBody>
+      </p:sp>
+      <p:sp>
+        <p:nvSpPr>
+          <p:cNvPr id="9" name="TextBox 8"/>
           <p:cNvSpPr txBox="1"/>
           <p:nvPr/>
         </p:nvSpPr>
         <p:spPr>
           <a:xfrm>
-            <a:off x="914400" y="1600200"/>
+            <a:off x="960120" y="1572768"/>
             <a:ext cx="3108960" cy="3017520"/>
           </a:xfrm>
           <a:prstGeom prst="rect">
@@ -7497,7 +8259,7 @@
           <a:lstStyle/>
           <a:p>
             <a:pPr>
-              <a:defRPr sz="1500" b="1">
+              <a:defRPr sz="1550" b="1">
                 <a:solidFill>
                   <a:srgbClr val="002D72"/>
                 </a:solidFill>
@@ -7514,7 +8276,7 @@
               </a:spcBef>
               <a:defRPr sz="1100" b="1">
                 <a:solidFill>
-                  <a:srgbClr val="018136"/>
+                  <a:srgbClr val="056DAE"/>
                 </a:solidFill>
               </a:defRPr>
             </a:pPr>
@@ -7529,7 +8291,7 @@
               </a:spcBef>
               <a:defRPr sz="1100">
                 <a:solidFill>
-                  <a:srgbClr val="212529"/>
+                  <a:srgbClr val="1E293B"/>
                 </a:solidFill>
               </a:defRPr>
             </a:pPr>
@@ -7546,20 +8308,20 @@
             </a:r>
             <a:br/>
             <a:r>
-              <a:t>• Full-width responsive Citibank portal</a:t>
-            </a:r>
-          </a:p>
-        </p:txBody>
-      </p:sp>
-      <p:sp>
-        <p:nvSpPr>
-          <p:cNvPr id="8" name="Rounded Rectangle 7"/>
+              <a:t>• Live responsive trade execution cockpit</a:t>
+            </a:r>
+          </a:p>
+        </p:txBody>
+      </p:sp>
+      <p:sp>
+        <p:nvSpPr>
+          <p:cNvPr id="10" name="Rounded Rectangle 9"/>
           <p:cNvSpPr/>
           <p:nvPr/>
         </p:nvSpPr>
         <p:spPr>
           <a:xfrm>
-            <a:off x="4343400" y="1371600"/>
+            <a:off x="4389120" y="1371600"/>
             <a:ext cx="3474720" cy="3474720"/>
           </a:xfrm>
           <a:prstGeom prst="roundRect">
@@ -7570,7 +8332,7 @@
           </a:solidFill>
           <a:ln w="15240">
             <a:solidFill>
-              <a:srgbClr val="E2E8F0"/>
+              <a:srgbClr val="D97706"/>
             </a:solidFill>
           </a:ln>
         </p:spPr>
@@ -7598,13 +8360,56 @@
       </p:sp>
       <p:sp>
         <p:nvSpPr>
-          <p:cNvPr id="9" name="TextBox 8"/>
+          <p:cNvPr id="11" name="Rectangle 10"/>
+          <p:cNvSpPr/>
+          <p:nvPr/>
+        </p:nvSpPr>
+        <p:spPr>
+          <a:xfrm>
+            <a:off x="4389120" y="1371600"/>
+            <a:ext cx="3474720" cy="73152"/>
+          </a:xfrm>
+          <a:prstGeom prst="rect">
+            <a:avLst/>
+          </a:prstGeom>
+          <a:solidFill>
+            <a:srgbClr val="D97706"/>
+          </a:solidFill>
+          <a:ln>
+            <a:noFill/>
+          </a:ln>
+        </p:spPr>
+        <p:style>
+          <a:lnRef idx="1">
+            <a:schemeClr val="accent1"/>
+          </a:lnRef>
+          <a:fillRef idx="3">
+            <a:schemeClr val="accent1"/>
+          </a:fillRef>
+          <a:effectRef idx="2">
+            <a:schemeClr val="accent1"/>
+          </a:effectRef>
+          <a:fontRef idx="minor">
+            <a:schemeClr val="lt1"/>
+          </a:fontRef>
+        </p:style>
+        <p:txBody>
+          <a:bodyPr rtlCol="0" anchor="ctr"/>
+          <a:lstStyle/>
+          <a:p>
+            <a:pPr algn="ctr"/>
+          </a:p>
+        </p:txBody>
+      </p:sp>
+      <p:sp>
+        <p:nvSpPr>
+          <p:cNvPr id="12" name="TextBox 11"/>
           <p:cNvSpPr txBox="1"/>
           <p:nvPr/>
         </p:nvSpPr>
         <p:spPr>
           <a:xfrm>
-            <a:off x="4526280" y="1600200"/>
+            <a:off x="4572000" y="1572768"/>
             <a:ext cx="3108960" cy="3017520"/>
           </a:xfrm>
           <a:prstGeom prst="rect">
@@ -7619,7 +8424,7 @@
           <a:lstStyle/>
           <a:p>
             <a:pPr>
-              <a:defRPr sz="1500" b="1">
+              <a:defRPr sz="1550" b="1">
                 <a:solidFill>
                   <a:srgbClr val="002D72"/>
                 </a:solidFill>
@@ -7636,7 +8441,7 @@
               </a:spcBef>
               <a:defRPr sz="1100" b="1">
                 <a:solidFill>
-                  <a:srgbClr val="056DAE"/>
+                  <a:srgbClr val="D97706"/>
                 </a:solidFill>
               </a:defRPr>
             </a:pPr>
@@ -7651,7 +8456,7 @@
               </a:spcBef>
               <a:defRPr sz="1100">
                 <a:solidFill>
-                  <a:srgbClr val="212529"/>
+                  <a:srgbClr val="1E293B"/>
                 </a:solidFill>
               </a:defRPr>
             </a:pPr>
@@ -7675,13 +8480,13 @@
       </p:sp>
       <p:sp>
         <p:nvSpPr>
-          <p:cNvPr id="10" name="Rounded Rectangle 9"/>
+          <p:cNvPr id="13" name="Rounded Rectangle 12"/>
           <p:cNvSpPr/>
           <p:nvPr/>
         </p:nvSpPr>
         <p:spPr>
           <a:xfrm>
-            <a:off x="7955280" y="1371600"/>
+            <a:off x="8001000" y="1371600"/>
             <a:ext cx="3474720" cy="3474720"/>
           </a:xfrm>
           <a:prstGeom prst="roundRect">
@@ -7692,7 +8497,7 @@
           </a:solidFill>
           <a:ln w="15240">
             <a:solidFill>
-              <a:srgbClr val="E2E8F0"/>
+              <a:srgbClr val="059669"/>
             </a:solidFill>
           </a:ln>
         </p:spPr>
@@ -7720,13 +8525,56 @@
       </p:sp>
       <p:sp>
         <p:nvSpPr>
-          <p:cNvPr id="11" name="TextBox 10"/>
+          <p:cNvPr id="14" name="Rectangle 13"/>
+          <p:cNvSpPr/>
+          <p:nvPr/>
+        </p:nvSpPr>
+        <p:spPr>
+          <a:xfrm>
+            <a:off x="8001000" y="1371600"/>
+            <a:ext cx="3474720" cy="73152"/>
+          </a:xfrm>
+          <a:prstGeom prst="rect">
+            <a:avLst/>
+          </a:prstGeom>
+          <a:solidFill>
+            <a:srgbClr val="059669"/>
+          </a:solidFill>
+          <a:ln>
+            <a:noFill/>
+          </a:ln>
+        </p:spPr>
+        <p:style>
+          <a:lnRef idx="1">
+            <a:schemeClr val="accent1"/>
+          </a:lnRef>
+          <a:fillRef idx="3">
+            <a:schemeClr val="accent1"/>
+          </a:fillRef>
+          <a:effectRef idx="2">
+            <a:schemeClr val="accent1"/>
+          </a:effectRef>
+          <a:fontRef idx="minor">
+            <a:schemeClr val="lt1"/>
+          </a:fontRef>
+        </p:style>
+        <p:txBody>
+          <a:bodyPr rtlCol="0" anchor="ctr"/>
+          <a:lstStyle/>
+          <a:p>
+            <a:pPr algn="ctr"/>
+          </a:p>
+        </p:txBody>
+      </p:sp>
+      <p:sp>
+        <p:nvSpPr>
+          <p:cNvPr id="15" name="TextBox 14"/>
           <p:cNvSpPr txBox="1"/>
           <p:nvPr/>
         </p:nvSpPr>
         <p:spPr>
           <a:xfrm>
-            <a:off x="8138160" y="1600200"/>
+            <a:off x="8183879" y="1572768"/>
             <a:ext cx="3108960" cy="3017520"/>
           </a:xfrm>
           <a:prstGeom prst="rect">
@@ -7741,7 +8589,7 @@
           <a:lstStyle/>
           <a:p>
             <a:pPr>
-              <a:defRPr sz="1500" b="1">
+              <a:defRPr sz="1550" b="1">
                 <a:solidFill>
                   <a:srgbClr val="002D72"/>
                 </a:solidFill>
@@ -7758,7 +8606,7 @@
               </a:spcBef>
               <a:defRPr sz="1100" b="1">
                 <a:solidFill>
-                  <a:srgbClr val="056DAE"/>
+                  <a:srgbClr val="059669"/>
                 </a:solidFill>
               </a:defRPr>
             </a:pPr>
@@ -7773,7 +8621,7 @@
               </a:spcBef>
               <a:defRPr sz="1100">
                 <a:solidFill>
-                  <a:srgbClr val="212529"/>
+                  <a:srgbClr val="1E293B"/>
                 </a:solidFill>
               </a:defRPr>
             </a:pPr>
@@ -7797,14 +8645,14 @@
       </p:sp>
       <p:sp>
         <p:nvSpPr>
-          <p:cNvPr id="12" name="Rounded Rectangle 11"/>
+          <p:cNvPr id="16" name="Rounded Rectangle 15"/>
           <p:cNvSpPr/>
           <p:nvPr/>
         </p:nvSpPr>
         <p:spPr>
           <a:xfrm>
-            <a:off x="731520" y="5029200"/>
-            <a:ext cx="10728655" cy="1188720"/>
+            <a:off x="777240" y="5029200"/>
+            <a:ext cx="10680192" cy="1234440"/>
           </a:xfrm>
           <a:prstGeom prst="roundRect">
             <a:avLst/>
@@ -7842,14 +8690,14 @@
       </p:sp>
       <p:sp>
         <p:nvSpPr>
-          <p:cNvPr id="13" name="TextBox 12"/>
+          <p:cNvPr id="17" name="TextBox 16"/>
           <p:cNvSpPr txBox="1"/>
           <p:nvPr/>
         </p:nvSpPr>
         <p:spPr>
           <a:xfrm>
-            <a:off x="960120" y="5166360"/>
-            <a:ext cx="10241280" cy="914400"/>
+            <a:off x="1005840" y="5138928"/>
+            <a:ext cx="10149840" cy="1005840"/>
           </a:xfrm>
           <a:prstGeom prst="rect">
             <a:avLst/>
@@ -7863,7 +8711,7 @@
           <a:lstStyle/>
           <a:p>
             <a:pPr>
-              <a:defRPr sz="1350" b="1">
+              <a:defRPr sz="1400" b="1">
                 <a:solidFill>
                   <a:srgbClr val="FFFFFF"/>
                 </a:solidFill>
@@ -7878,14 +8726,14 @@
               <a:spcBef>
                 <a:spcPts val="400"/>
               </a:spcBef>
-              <a:defRPr sz="1100">
+              <a:defRPr sz="1150">
                 <a:solidFill>
                   <a:srgbClr val="B4D7F5"/>
                 </a:solidFill>
               </a:defRPr>
             </a:pPr>
             <a:r>
-              <a:t>Built for the Drunix Hackathon 2026 | Citi Treasury and Trade Solutions × India Blockchain Forum</a:t>
+              <a:t>Built for the Drunix Hackathon 2026 | Citigroup Inc. × India Blockchain Forum | Challenge CHL-7007</a:t>
             </a:r>
           </a:p>
         </p:txBody>

</xml_diff>